<commit_message>
Restyle Q4Q5 with exact Rollout color scheme: cream bg, Calibri, no dark teal
</commit_message>
<xml_diff>
--- a/Q4Q5_Final_9slides_restyled.pptx
+++ b/Q4Q5_Final_9slides_restyled.pptx
@@ -1680,9 +1680,9 @@
             <a:r>
               <a:rPr lang="en-US" sz="625" b="1" spc="300" kern="0" dirty="0">
                 <a:solidFill>
-                  <a:srgbClr val="E2C8B5"/>
-                </a:solidFill>
-                <a:latin typeface="Open Sans" pitchFamily="34" charset="0"/>
+                  <a:srgbClr val="AF2C20"/>
+                </a:solidFill>
+                <a:latin typeface="Calibri" pitchFamily="34" charset="0"/>
                 <a:ea typeface="Open Sans" pitchFamily="34" charset="-122"/>
                 <a:cs typeface="Open Sans" pitchFamily="34" charset="-120"/>
               </a:rPr>
@@ -1719,9 +1719,9 @@
             <a:r>
               <a:rPr lang="en-US" sz="3250" b="1" dirty="0">
                 <a:solidFill>
-                  <a:srgbClr val="FFFFFF"/>
-                </a:solidFill>
-                <a:latin typeface="Bitter" pitchFamily="34" charset="0"/>
+                  <a:srgbClr val="2B2E3C"/>
+                </a:solidFill>
+                <a:latin typeface="Calibri" pitchFamily="34" charset="0"/>
                 <a:ea typeface="Bitter" pitchFamily="34" charset="-122"/>
                 <a:cs typeface="Bitter" pitchFamily="34" charset="-120"/>
               </a:rPr>
@@ -1736,9 +1736,9 @@
             <a:r>
               <a:rPr lang="en-US" sz="3250" b="1" dirty="0">
                 <a:solidFill>
-                  <a:srgbClr val="FFFFFF"/>
-                </a:solidFill>
-                <a:latin typeface="Bitter" pitchFamily="34" charset="0"/>
+                  <a:srgbClr val="2B2E3C"/>
+                </a:solidFill>
+                <a:latin typeface="Calibri" pitchFamily="34" charset="0"/>
                 <a:ea typeface="Bitter" pitchFamily="34" charset="-122"/>
                 <a:cs typeface="Bitter" pitchFamily="34" charset="-120"/>
               </a:rPr>
@@ -1753,9 +1753,9 @@
             <a:r>
               <a:rPr lang="en-US" sz="3250" b="1" dirty="0">
                 <a:solidFill>
-                  <a:srgbClr val="FFFFFF"/>
-                </a:solidFill>
-                <a:latin typeface="Bitter" pitchFamily="34" charset="0"/>
+                  <a:srgbClr val="2B2E3C"/>
+                </a:solidFill>
+                <a:latin typeface="Calibri" pitchFamily="34" charset="0"/>
                 <a:ea typeface="Bitter" pitchFamily="34" charset="-122"/>
                 <a:cs typeface="Bitter" pitchFamily="34" charset="-120"/>
               </a:rPr>
@@ -1792,9 +1792,9 @@
             <a:r>
               <a:rPr lang="en-US" sz="812" i="1" dirty="0">
                 <a:solidFill>
-                  <a:srgbClr val="AABCB6"/>
-                </a:solidFill>
-                <a:latin typeface="Roboto" pitchFamily="34" charset="0"/>
+                  <a:srgbClr val="2B2E3C"/>
+                </a:solidFill>
+                <a:latin typeface="Calibri" pitchFamily="34" charset="0"/>
                 <a:ea typeface="Roboto" pitchFamily="34" charset="-122"/>
                 <a:cs typeface="Roboto" pitchFamily="34" charset="-120"/>
               </a:rPr>
@@ -1860,9 +1860,9 @@
             <a:r>
               <a:rPr lang="en-US" sz="687" b="1" dirty="0">
                 <a:solidFill>
-                  <a:srgbClr val="FFFFFF"/>
-                </a:solidFill>
-                <a:latin typeface="Open Sans" pitchFamily="34" charset="0"/>
+                  <a:srgbClr val="2B2E3C"/>
+                </a:solidFill>
+                <a:latin typeface="Calibri" pitchFamily="34" charset="0"/>
                 <a:ea typeface="Open Sans" pitchFamily="34" charset="-122"/>
                 <a:cs typeface="Open Sans" pitchFamily="34" charset="-120"/>
               </a:rPr>
@@ -1928,9 +1928,9 @@
             <a:r>
               <a:rPr lang="en-US" sz="625" dirty="0">
                 <a:solidFill>
-                  <a:srgbClr val="FFFFFF"/>
-                </a:solidFill>
-                <a:latin typeface="Open Sans" pitchFamily="34" charset="0"/>
+                  <a:srgbClr val="2B2E3C"/>
+                </a:solidFill>
+                <a:latin typeface="Calibri" pitchFamily="34" charset="0"/>
                 <a:ea typeface="Open Sans" pitchFamily="34" charset="-122"/>
                 <a:cs typeface="Open Sans" pitchFamily="34" charset="-120"/>
               </a:rPr>
@@ -1987,7 +1987,7 @@
             <a:avLst/>
           </a:prstGeom>
           <a:solidFill>
-            <a:srgbClr val="2C3F42"/>
+            <a:srgbClr val="FFF8F0"/>
           </a:solidFill>
           <a:ln w="12700">
             <a:solidFill>
@@ -2028,9 +2028,9 @@
             <a:r>
               <a:rPr lang="en-US" sz="531" b="1" spc="300" kern="0" dirty="0">
                 <a:solidFill>
-                  <a:srgbClr val="E2C8B5"/>
-                </a:solidFill>
-                <a:latin typeface="Open Sans" pitchFamily="34" charset="0"/>
+                  <a:srgbClr val="AF2C20"/>
+                </a:solidFill>
+                <a:latin typeface="Calibri" pitchFamily="34" charset="0"/>
                 <a:ea typeface="Open Sans" pitchFamily="34" charset="-122"/>
                 <a:cs typeface="Open Sans" pitchFamily="34" charset="-120"/>
               </a:rPr>
@@ -2067,9 +2067,9 @@
             <a:r>
               <a:rPr lang="en-US" sz="1500" b="1" dirty="0">
                 <a:solidFill>
-                  <a:srgbClr val="FFFFFF"/>
-                </a:solidFill>
-                <a:latin typeface="Bitter" pitchFamily="34" charset="0"/>
+                  <a:srgbClr val="2B2E3C"/>
+                </a:solidFill>
+                <a:latin typeface="Calibri" pitchFamily="34" charset="0"/>
                 <a:ea typeface="Bitter" pitchFamily="34" charset="-122"/>
                 <a:cs typeface="Bitter" pitchFamily="34" charset="-120"/>
               </a:rPr>
@@ -2139,7 +2139,7 @@
                 <a:solidFill>
                   <a:srgbClr val="2B2E3C"/>
                 </a:solidFill>
-                <a:latin typeface="Roboto" pitchFamily="34" charset="0"/>
+                <a:latin typeface="Calibri" pitchFamily="34" charset="0"/>
                 <a:ea typeface="Roboto" pitchFamily="34" charset="-122"/>
                 <a:cs typeface="Roboto" pitchFamily="34" charset="-120"/>
               </a:rPr>
@@ -2164,7 +2164,7 @@
             <a:avLst/>
           </a:prstGeom>
           <a:solidFill>
-            <a:srgbClr val="2C3F42"/>
+            <a:srgbClr val="FFF8F0"/>
           </a:solidFill>
           <a:ln w="12700">
             <a:solidFill>
@@ -2205,9 +2205,9 @@
             <a:r>
               <a:rPr lang="en-US" sz="593" b="1" spc="150" kern="0" dirty="0">
                 <a:solidFill>
-                  <a:srgbClr val="E2C8B5"/>
-                </a:solidFill>
-                <a:latin typeface="Bitter" pitchFamily="34" charset="0"/>
+                  <a:srgbClr val="AF2C20"/>
+                </a:solidFill>
+                <a:latin typeface="Calibri" pitchFamily="34" charset="0"/>
                 <a:ea typeface="Bitter" pitchFamily="34" charset="-122"/>
                 <a:cs typeface="Bitter" pitchFamily="34" charset="-120"/>
               </a:rPr>
@@ -2244,9 +2244,9 @@
             <a:r>
               <a:rPr lang="en-US" sz="625" dirty="0">
                 <a:solidFill>
-                  <a:srgbClr val="FFFFFF"/>
-                </a:solidFill>
-                <a:latin typeface="Roboto" pitchFamily="34" charset="0"/>
+                  <a:srgbClr val="2B2E3C"/>
+                </a:solidFill>
+                <a:latin typeface="Calibri" pitchFamily="34" charset="0"/>
                 <a:ea typeface="Roboto" pitchFamily="34" charset="-122"/>
                 <a:cs typeface="Roboto" pitchFamily="34" charset="-120"/>
               </a:rPr>
@@ -2339,9 +2339,9 @@
             <a:r>
               <a:rPr lang="en-US" sz="593" b="1" spc="150" kern="0" dirty="0">
                 <a:solidFill>
-                  <a:srgbClr val="FFFFFF"/>
-                </a:solidFill>
-                <a:latin typeface="Bitter" pitchFamily="34" charset="0"/>
+                  <a:srgbClr val="2B2E3C"/>
+                </a:solidFill>
+                <a:latin typeface="Calibri" pitchFamily="34" charset="0"/>
                 <a:ea typeface="Bitter" pitchFamily="34" charset="-122"/>
                 <a:cs typeface="Bitter" pitchFamily="34" charset="-120"/>
               </a:rPr>
@@ -2378,9 +2378,9 @@
             <a:r>
               <a:rPr lang="en-US" sz="625" dirty="0">
                 <a:solidFill>
-                  <a:srgbClr val="FFFFFF"/>
-                </a:solidFill>
-                <a:latin typeface="Roboto" pitchFamily="34" charset="0"/>
+                  <a:srgbClr val="2B2E3C"/>
+                </a:solidFill>
+                <a:latin typeface="Calibri" pitchFamily="34" charset="0"/>
                 <a:ea typeface="Roboto" pitchFamily="34" charset="-122"/>
                 <a:cs typeface="Roboto" pitchFamily="34" charset="-120"/>
               </a:rPr>
@@ -2583,9 +2583,9 @@
             <a:r>
               <a:rPr lang="en-US" sz="750" b="1" dirty="0">
                 <a:solidFill>
-                  <a:srgbClr val="FFFFFF"/>
-                </a:solidFill>
-                <a:latin typeface="Bitter" pitchFamily="34" charset="0"/>
+                  <a:srgbClr val="2B2E3C"/>
+                </a:solidFill>
+                <a:latin typeface="Calibri" pitchFamily="34" charset="0"/>
                 <a:ea typeface="Bitter" pitchFamily="34" charset="-122"/>
                 <a:cs typeface="Bitter" pitchFamily="34" charset="-120"/>
               </a:rPr>
@@ -2625,7 +2625,7 @@
                 <a:solidFill>
                   <a:srgbClr val="2B2E3C"/>
                 </a:solidFill>
-                <a:latin typeface="Roboto" pitchFamily="34" charset="0"/>
+                <a:latin typeface="Calibri" pitchFamily="34" charset="0"/>
                 <a:ea typeface="Roboto" pitchFamily="34" charset="-122"/>
                 <a:cs typeface="Roboto" pitchFamily="34" charset="-120"/>
               </a:rPr>
@@ -2665,7 +2665,7 @@
                 <a:solidFill>
                   <a:srgbClr val="2B2E3C"/>
                 </a:solidFill>
-                <a:latin typeface="Roboto" pitchFamily="34" charset="0"/>
+                <a:latin typeface="Calibri" pitchFamily="34" charset="0"/>
                 <a:ea typeface="Roboto" pitchFamily="34" charset="-122"/>
                 <a:cs typeface="Roboto" pitchFamily="34" charset="-120"/>
               </a:rPr>
@@ -2705,7 +2705,7 @@
                 <a:solidFill>
                   <a:srgbClr val="2B2E3C"/>
                 </a:solidFill>
-                <a:latin typeface="Roboto" pitchFamily="34" charset="0"/>
+                <a:latin typeface="Calibri" pitchFamily="34" charset="0"/>
                 <a:ea typeface="Roboto" pitchFamily="34" charset="-122"/>
                 <a:cs typeface="Roboto" pitchFamily="34" charset="-120"/>
               </a:rPr>
@@ -2745,7 +2745,7 @@
                 <a:solidFill>
                   <a:srgbClr val="2B2E3C"/>
                 </a:solidFill>
-                <a:latin typeface="Roboto" pitchFamily="34" charset="0"/>
+                <a:latin typeface="Calibri" pitchFamily="34" charset="0"/>
                 <a:ea typeface="Roboto" pitchFamily="34" charset="-122"/>
                 <a:cs typeface="Roboto" pitchFamily="34" charset="-120"/>
               </a:rPr>
@@ -2840,9 +2840,9 @@
             <a:r>
               <a:rPr lang="en-US" sz="750" b="1" dirty="0">
                 <a:solidFill>
-                  <a:srgbClr val="FFFFFF"/>
-                </a:solidFill>
-                <a:latin typeface="Bitter" pitchFamily="34" charset="0"/>
+                  <a:srgbClr val="2B2E3C"/>
+                </a:solidFill>
+                <a:latin typeface="Calibri" pitchFamily="34" charset="0"/>
                 <a:ea typeface="Bitter" pitchFamily="34" charset="-122"/>
                 <a:cs typeface="Bitter" pitchFamily="34" charset="-120"/>
               </a:rPr>
@@ -2882,7 +2882,7 @@
                 <a:solidFill>
                   <a:srgbClr val="2B2E3C"/>
                 </a:solidFill>
-                <a:latin typeface="Roboto" pitchFamily="34" charset="0"/>
+                <a:latin typeface="Calibri" pitchFamily="34" charset="0"/>
                 <a:ea typeface="Roboto" pitchFamily="34" charset="-122"/>
                 <a:cs typeface="Roboto" pitchFamily="34" charset="-120"/>
               </a:rPr>
@@ -2922,7 +2922,7 @@
                 <a:solidFill>
                   <a:srgbClr val="2B2E3C"/>
                 </a:solidFill>
-                <a:latin typeface="Roboto" pitchFamily="34" charset="0"/>
+                <a:latin typeface="Calibri" pitchFamily="34" charset="0"/>
                 <a:ea typeface="Roboto" pitchFamily="34" charset="-122"/>
                 <a:cs typeface="Roboto" pitchFamily="34" charset="-120"/>
               </a:rPr>
@@ -2962,7 +2962,7 @@
                 <a:solidFill>
                   <a:srgbClr val="2B2E3C"/>
                 </a:solidFill>
-                <a:latin typeface="Roboto" pitchFamily="34" charset="0"/>
+                <a:latin typeface="Calibri" pitchFamily="34" charset="0"/>
                 <a:ea typeface="Roboto" pitchFamily="34" charset="-122"/>
                 <a:cs typeface="Roboto" pitchFamily="34" charset="-120"/>
               </a:rPr>
@@ -3002,7 +3002,7 @@
                 <a:solidFill>
                   <a:srgbClr val="2B2E3C"/>
                 </a:solidFill>
-                <a:latin typeface="Roboto" pitchFamily="34" charset="0"/>
+                <a:latin typeface="Calibri" pitchFamily="34" charset="0"/>
                 <a:ea typeface="Roboto" pitchFamily="34" charset="-122"/>
                 <a:cs typeface="Roboto" pitchFamily="34" charset="-120"/>
               </a:rPr>
@@ -3097,9 +3097,9 @@
             <a:r>
               <a:rPr lang="en-US" sz="750" b="1" dirty="0">
                 <a:solidFill>
-                  <a:srgbClr val="FFFFFF"/>
-                </a:solidFill>
-                <a:latin typeface="Bitter" pitchFamily="34" charset="0"/>
+                  <a:srgbClr val="2B2E3C"/>
+                </a:solidFill>
+                <a:latin typeface="Calibri" pitchFamily="34" charset="0"/>
                 <a:ea typeface="Bitter" pitchFamily="34" charset="-122"/>
                 <a:cs typeface="Bitter" pitchFamily="34" charset="-120"/>
               </a:rPr>
@@ -3139,7 +3139,7 @@
                 <a:solidFill>
                   <a:srgbClr val="2B2E3C"/>
                 </a:solidFill>
-                <a:latin typeface="Roboto" pitchFamily="34" charset="0"/>
+                <a:latin typeface="Calibri" pitchFamily="34" charset="0"/>
                 <a:ea typeface="Roboto" pitchFamily="34" charset="-122"/>
                 <a:cs typeface="Roboto" pitchFamily="34" charset="-120"/>
               </a:rPr>
@@ -3179,7 +3179,7 @@
                 <a:solidFill>
                   <a:srgbClr val="2B2E3C"/>
                 </a:solidFill>
-                <a:latin typeface="Roboto" pitchFamily="34" charset="0"/>
+                <a:latin typeface="Calibri" pitchFamily="34" charset="0"/>
                 <a:ea typeface="Roboto" pitchFamily="34" charset="-122"/>
                 <a:cs typeface="Roboto" pitchFamily="34" charset="-120"/>
               </a:rPr>
@@ -3219,7 +3219,7 @@
                 <a:solidFill>
                   <a:srgbClr val="2B2E3C"/>
                 </a:solidFill>
-                <a:latin typeface="Roboto" pitchFamily="34" charset="0"/>
+                <a:latin typeface="Calibri" pitchFamily="34" charset="0"/>
                 <a:ea typeface="Roboto" pitchFamily="34" charset="-122"/>
                 <a:cs typeface="Roboto" pitchFamily="34" charset="-120"/>
               </a:rPr>
@@ -3259,7 +3259,7 @@
                 <a:solidFill>
                   <a:srgbClr val="2B2E3C"/>
                 </a:solidFill>
-                <a:latin typeface="Roboto" pitchFamily="34" charset="0"/>
+                <a:latin typeface="Calibri" pitchFamily="34" charset="0"/>
                 <a:ea typeface="Roboto" pitchFamily="34" charset="-122"/>
                 <a:cs typeface="Roboto" pitchFamily="34" charset="-120"/>
               </a:rPr>
@@ -3296,9 +3296,9 @@
             <a:r>
               <a:rPr lang="en-US" sz="531" i="1" dirty="0">
                 <a:solidFill>
-                  <a:srgbClr val="64748B"/>
-                </a:solidFill>
-                <a:latin typeface="Open Sans" pitchFamily="34" charset="0"/>
+                  <a:srgbClr val="2B2E3C"/>
+                </a:solidFill>
+                <a:latin typeface="Calibri" pitchFamily="34" charset="0"/>
                 <a:ea typeface="Open Sans" pitchFamily="34" charset="-122"/>
                 <a:cs typeface="Open Sans" pitchFamily="34" charset="-120"/>
               </a:rPr>
@@ -3355,7 +3355,7 @@
             <a:avLst/>
           </a:prstGeom>
           <a:solidFill>
-            <a:srgbClr val="2C3F42"/>
+            <a:srgbClr val="FFF8F0"/>
           </a:solidFill>
           <a:ln w="12700">
             <a:solidFill>
@@ -3396,9 +3396,9 @@
             <a:r>
               <a:rPr lang="en-US" sz="531" b="1" spc="300" kern="0" dirty="0">
                 <a:solidFill>
-                  <a:srgbClr val="E2C8B5"/>
-                </a:solidFill>
-                <a:latin typeface="Open Sans" pitchFamily="34" charset="0"/>
+                  <a:srgbClr val="AF2C20"/>
+                </a:solidFill>
+                <a:latin typeface="Calibri" pitchFamily="34" charset="0"/>
                 <a:ea typeface="Open Sans" pitchFamily="34" charset="-122"/>
                 <a:cs typeface="Open Sans" pitchFamily="34" charset="-120"/>
               </a:rPr>
@@ -3435,9 +3435,9 @@
             <a:r>
               <a:rPr lang="en-US" sz="1500" b="1" dirty="0">
                 <a:solidFill>
-                  <a:srgbClr val="FFFFFF"/>
-                </a:solidFill>
-                <a:latin typeface="Bitter" pitchFamily="34" charset="0"/>
+                  <a:srgbClr val="2B2E3C"/>
+                </a:solidFill>
+                <a:latin typeface="Calibri" pitchFamily="34" charset="0"/>
                 <a:ea typeface="Bitter" pitchFamily="34" charset="-122"/>
                 <a:cs typeface="Bitter" pitchFamily="34" charset="-120"/>
               </a:rPr>
@@ -3532,9 +3532,9 @@
             <a:r>
               <a:rPr lang="en-US" sz="656" b="1" dirty="0">
                 <a:solidFill>
-                  <a:srgbClr val="FFFFFF"/>
-                </a:solidFill>
-                <a:latin typeface="Bitter" pitchFamily="34" charset="0"/>
+                  <a:srgbClr val="2B2E3C"/>
+                </a:solidFill>
+                <a:latin typeface="Calibri" pitchFamily="34" charset="0"/>
                 <a:ea typeface="Bitter" pitchFamily="34" charset="-122"/>
                 <a:cs typeface="Bitter" pitchFamily="34" charset="-120"/>
               </a:rPr>
@@ -3573,7 +3573,7 @@
                 <a:solidFill>
                   <a:srgbClr val="2B2E3C"/>
                 </a:solidFill>
-                <a:latin typeface="Roboto" pitchFamily="34" charset="0"/>
+                <a:latin typeface="Calibri" pitchFamily="34" charset="0"/>
                 <a:ea typeface="Roboto" pitchFamily="34" charset="-122"/>
                 <a:cs typeface="Roboto" pitchFamily="34" charset="-120"/>
               </a:rPr>
@@ -3588,7 +3588,7 @@
                 <a:solidFill>
                   <a:srgbClr val="2B2E3C"/>
                 </a:solidFill>
-                <a:latin typeface="Roboto" pitchFamily="34" charset="0"/>
+                <a:latin typeface="Calibri" pitchFamily="34" charset="0"/>
                 <a:ea typeface="Roboto" pitchFamily="34" charset="-122"/>
                 <a:cs typeface="Roboto" pitchFamily="34" charset="-120"/>
               </a:rPr>
@@ -3603,7 +3603,7 @@
                 <a:solidFill>
                   <a:srgbClr val="2B2E3C"/>
                 </a:solidFill>
-                <a:latin typeface="Roboto" pitchFamily="34" charset="0"/>
+                <a:latin typeface="Calibri" pitchFamily="34" charset="0"/>
                 <a:ea typeface="Roboto" pitchFamily="34" charset="-122"/>
                 <a:cs typeface="Roboto" pitchFamily="34" charset="-120"/>
               </a:rPr>
@@ -3698,9 +3698,9 @@
             <a:r>
               <a:rPr lang="en-US" sz="656" b="1" dirty="0">
                 <a:solidFill>
-                  <a:srgbClr val="FFFFFF"/>
-                </a:solidFill>
-                <a:latin typeface="Bitter" pitchFamily="34" charset="0"/>
+                  <a:srgbClr val="2B2E3C"/>
+                </a:solidFill>
+                <a:latin typeface="Calibri" pitchFamily="34" charset="0"/>
                 <a:ea typeface="Bitter" pitchFamily="34" charset="-122"/>
                 <a:cs typeface="Bitter" pitchFamily="34" charset="-120"/>
               </a:rPr>
@@ -3725,7 +3725,7 @@
             <a:avLst/>
           </a:prstGeom>
           <a:solidFill>
-            <a:srgbClr val="2C3F42"/>
+            <a:srgbClr val="FFF8F0"/>
           </a:solidFill>
           <a:ln w="12700">
             <a:solidFill>
@@ -3766,9 +3766,9 @@
             <a:r>
               <a:rPr lang="en-US" sz="500" b="1" dirty="0">
                 <a:solidFill>
-                  <a:srgbClr val="FFFFFF"/>
-                </a:solidFill>
-                <a:latin typeface="Bitter" pitchFamily="34" charset="0"/>
+                  <a:srgbClr val="2B2E3C"/>
+                </a:solidFill>
+                <a:latin typeface="Calibri" pitchFamily="34" charset="0"/>
                 <a:ea typeface="Bitter" pitchFamily="34" charset="-122"/>
                 <a:cs typeface="Bitter" pitchFamily="34" charset="-120"/>
               </a:rPr>
@@ -3793,7 +3793,7 @@
             <a:avLst/>
           </a:prstGeom>
           <a:solidFill>
-            <a:srgbClr val="2C3F42"/>
+            <a:srgbClr val="FFF8F0"/>
           </a:solidFill>
           <a:ln w="12700">
             <a:solidFill>
@@ -3834,9 +3834,9 @@
             <a:r>
               <a:rPr lang="en-US" sz="500" b="1" dirty="0">
                 <a:solidFill>
-                  <a:srgbClr val="FFFFFF"/>
-                </a:solidFill>
-                <a:latin typeface="Bitter" pitchFamily="34" charset="0"/>
+                  <a:srgbClr val="2B2E3C"/>
+                </a:solidFill>
+                <a:latin typeface="Calibri" pitchFamily="34" charset="0"/>
                 <a:ea typeface="Bitter" pitchFamily="34" charset="-122"/>
                 <a:cs typeface="Bitter" pitchFamily="34" charset="-120"/>
               </a:rPr>
@@ -3861,7 +3861,7 @@
             <a:avLst/>
           </a:prstGeom>
           <a:solidFill>
-            <a:srgbClr val="2C3F42"/>
+            <a:srgbClr val="FFF8F0"/>
           </a:solidFill>
           <a:ln w="12700">
             <a:solidFill>
@@ -3902,9 +3902,9 @@
             <a:r>
               <a:rPr lang="en-US" sz="500" b="1" dirty="0">
                 <a:solidFill>
-                  <a:srgbClr val="FFFFFF"/>
-                </a:solidFill>
-                <a:latin typeface="Bitter" pitchFamily="34" charset="0"/>
+                  <a:srgbClr val="2B2E3C"/>
+                </a:solidFill>
+                <a:latin typeface="Calibri" pitchFamily="34" charset="0"/>
                 <a:ea typeface="Bitter" pitchFamily="34" charset="-122"/>
                 <a:cs typeface="Bitter" pitchFamily="34" charset="-120"/>
               </a:rPr>
@@ -3929,7 +3929,7 @@
             <a:avLst/>
           </a:prstGeom>
           <a:solidFill>
-            <a:srgbClr val="2C3F42"/>
+            <a:srgbClr val="FFF8F0"/>
           </a:solidFill>
           <a:ln w="12700">
             <a:solidFill>
@@ -3970,9 +3970,9 @@
             <a:r>
               <a:rPr lang="en-US" sz="500" b="1" dirty="0">
                 <a:solidFill>
-                  <a:srgbClr val="FFFFFF"/>
-                </a:solidFill>
-                <a:latin typeface="Bitter" pitchFamily="34" charset="0"/>
+                  <a:srgbClr val="2B2E3C"/>
+                </a:solidFill>
+                <a:latin typeface="Calibri" pitchFamily="34" charset="0"/>
                 <a:ea typeface="Bitter" pitchFamily="34" charset="-122"/>
                 <a:cs typeface="Bitter" pitchFamily="34" charset="-120"/>
               </a:rPr>
@@ -3997,7 +3997,7 @@
             <a:avLst/>
           </a:prstGeom>
           <a:solidFill>
-            <a:srgbClr val="2C3F42"/>
+            <a:srgbClr val="FFF8F0"/>
           </a:solidFill>
           <a:ln w="12700">
             <a:solidFill>
@@ -4038,9 +4038,9 @@
             <a:r>
               <a:rPr lang="en-US" sz="500" b="1" dirty="0">
                 <a:solidFill>
-                  <a:srgbClr val="FFFFFF"/>
-                </a:solidFill>
-                <a:latin typeface="Bitter" pitchFamily="34" charset="0"/>
+                  <a:srgbClr val="2B2E3C"/>
+                </a:solidFill>
+                <a:latin typeface="Calibri" pitchFamily="34" charset="0"/>
                 <a:ea typeface="Bitter" pitchFamily="34" charset="-122"/>
                 <a:cs typeface="Bitter" pitchFamily="34" charset="-120"/>
               </a:rPr>
@@ -4108,7 +4108,7 @@
                 <a:solidFill>
                   <a:srgbClr val="2B2E3C"/>
                 </a:solidFill>
-                <a:latin typeface="Roboto" pitchFamily="34" charset="0"/>
+                <a:latin typeface="Calibri" pitchFamily="34" charset="0"/>
                 <a:ea typeface="Roboto" pitchFamily="34" charset="-122"/>
                 <a:cs typeface="Roboto" pitchFamily="34" charset="-120"/>
               </a:rPr>
@@ -4176,7 +4176,7 @@
                 <a:solidFill>
                   <a:srgbClr val="2B2E3C"/>
                 </a:solidFill>
-                <a:latin typeface="Roboto" pitchFamily="34" charset="0"/>
+                <a:latin typeface="Calibri" pitchFamily="34" charset="0"/>
                 <a:ea typeface="Roboto" pitchFamily="34" charset="-122"/>
                 <a:cs typeface="Roboto" pitchFamily="34" charset="-120"/>
               </a:rPr>
@@ -4244,7 +4244,7 @@
                 <a:solidFill>
                   <a:srgbClr val="2B2E3C"/>
                 </a:solidFill>
-                <a:latin typeface="Roboto" pitchFamily="34" charset="0"/>
+                <a:latin typeface="Calibri" pitchFamily="34" charset="0"/>
                 <a:ea typeface="Roboto" pitchFamily="34" charset="-122"/>
                 <a:cs typeface="Roboto" pitchFamily="34" charset="-120"/>
               </a:rPr>
@@ -4312,7 +4312,7 @@
                 <a:solidFill>
                   <a:srgbClr val="2B2E3C"/>
                 </a:solidFill>
-                <a:latin typeface="Roboto" pitchFamily="34" charset="0"/>
+                <a:latin typeface="Calibri" pitchFamily="34" charset="0"/>
                 <a:ea typeface="Roboto" pitchFamily="34" charset="-122"/>
                 <a:cs typeface="Roboto" pitchFamily="34" charset="-120"/>
               </a:rPr>
@@ -4380,7 +4380,7 @@
                 <a:solidFill>
                   <a:srgbClr val="2B2E3C"/>
                 </a:solidFill>
-                <a:latin typeface="Roboto" pitchFamily="34" charset="0"/>
+                <a:latin typeface="Calibri" pitchFamily="34" charset="0"/>
                 <a:ea typeface="Roboto" pitchFamily="34" charset="-122"/>
                 <a:cs typeface="Roboto" pitchFamily="34" charset="-120"/>
               </a:rPr>
@@ -4405,7 +4405,7 @@
             <a:avLst/>
           </a:prstGeom>
           <a:solidFill>
-            <a:srgbClr val="F9FAFD"/>
+            <a:srgbClr val="FFFFFF"/>
           </a:solidFill>
           <a:ln w="12700">
             <a:solidFill>
@@ -4448,7 +4448,7 @@
                 <a:solidFill>
                   <a:srgbClr val="2B2E3C"/>
                 </a:solidFill>
-                <a:latin typeface="Roboto" pitchFamily="34" charset="0"/>
+                <a:latin typeface="Calibri" pitchFamily="34" charset="0"/>
                 <a:ea typeface="Roboto" pitchFamily="34" charset="-122"/>
                 <a:cs typeface="Roboto" pitchFamily="34" charset="-120"/>
               </a:rPr>
@@ -4473,7 +4473,7 @@
             <a:avLst/>
           </a:prstGeom>
           <a:solidFill>
-            <a:srgbClr val="F9FAFD"/>
+            <a:srgbClr val="FFFFFF"/>
           </a:solidFill>
           <a:ln w="12700">
             <a:solidFill>
@@ -4516,7 +4516,7 @@
                 <a:solidFill>
                   <a:srgbClr val="2B2E3C"/>
                 </a:solidFill>
-                <a:latin typeface="Roboto" pitchFamily="34" charset="0"/>
+                <a:latin typeface="Calibri" pitchFamily="34" charset="0"/>
                 <a:ea typeface="Roboto" pitchFamily="34" charset="-122"/>
                 <a:cs typeface="Roboto" pitchFamily="34" charset="-120"/>
               </a:rPr>
@@ -4541,7 +4541,7 @@
             <a:avLst/>
           </a:prstGeom>
           <a:solidFill>
-            <a:srgbClr val="F9FAFD"/>
+            <a:srgbClr val="FFFFFF"/>
           </a:solidFill>
           <a:ln w="12700">
             <a:solidFill>
@@ -4584,7 +4584,7 @@
                 <a:solidFill>
                   <a:srgbClr val="2B2E3C"/>
                 </a:solidFill>
-                <a:latin typeface="Roboto" pitchFamily="34" charset="0"/>
+                <a:latin typeface="Calibri" pitchFamily="34" charset="0"/>
                 <a:ea typeface="Roboto" pitchFamily="34" charset="-122"/>
                 <a:cs typeface="Roboto" pitchFamily="34" charset="-120"/>
               </a:rPr>
@@ -4609,7 +4609,7 @@
             <a:avLst/>
           </a:prstGeom>
           <a:solidFill>
-            <a:srgbClr val="F9FAFD"/>
+            <a:srgbClr val="FFFFFF"/>
           </a:solidFill>
           <a:ln w="12700">
             <a:solidFill>
@@ -4652,7 +4652,7 @@
                 <a:solidFill>
                   <a:srgbClr val="2B2E3C"/>
                 </a:solidFill>
-                <a:latin typeface="Roboto" pitchFamily="34" charset="0"/>
+                <a:latin typeface="Calibri" pitchFamily="34" charset="0"/>
                 <a:ea typeface="Roboto" pitchFamily="34" charset="-122"/>
                 <a:cs typeface="Roboto" pitchFamily="34" charset="-120"/>
               </a:rPr>
@@ -4677,7 +4677,7 @@
             <a:avLst/>
           </a:prstGeom>
           <a:solidFill>
-            <a:srgbClr val="F9FAFD"/>
+            <a:srgbClr val="FFFFFF"/>
           </a:solidFill>
           <a:ln w="12700">
             <a:solidFill>
@@ -4720,7 +4720,7 @@
                 <a:solidFill>
                   <a:srgbClr val="2B2E3C"/>
                 </a:solidFill>
-                <a:latin typeface="Roboto" pitchFamily="34" charset="0"/>
+                <a:latin typeface="Calibri" pitchFamily="34" charset="0"/>
                 <a:ea typeface="Roboto" pitchFamily="34" charset="-122"/>
                 <a:cs typeface="Roboto" pitchFamily="34" charset="-120"/>
               </a:rPr>
@@ -4788,7 +4788,7 @@
                 <a:solidFill>
                   <a:srgbClr val="2B2E3C"/>
                 </a:solidFill>
-                <a:latin typeface="Roboto" pitchFamily="34" charset="0"/>
+                <a:latin typeface="Calibri" pitchFamily="34" charset="0"/>
                 <a:ea typeface="Roboto" pitchFamily="34" charset="-122"/>
                 <a:cs typeface="Roboto" pitchFamily="34" charset="-120"/>
               </a:rPr>
@@ -4856,7 +4856,7 @@
                 <a:solidFill>
                   <a:srgbClr val="2B2E3C"/>
                 </a:solidFill>
-                <a:latin typeface="Roboto" pitchFamily="34" charset="0"/>
+                <a:latin typeface="Calibri" pitchFamily="34" charset="0"/>
                 <a:ea typeface="Roboto" pitchFamily="34" charset="-122"/>
                 <a:cs typeface="Roboto" pitchFamily="34" charset="-120"/>
               </a:rPr>
@@ -4924,7 +4924,7 @@
                 <a:solidFill>
                   <a:srgbClr val="2B2E3C"/>
                 </a:solidFill>
-                <a:latin typeface="Roboto" pitchFamily="34" charset="0"/>
+                <a:latin typeface="Calibri" pitchFamily="34" charset="0"/>
                 <a:ea typeface="Roboto" pitchFamily="34" charset="-122"/>
                 <a:cs typeface="Roboto" pitchFamily="34" charset="-120"/>
               </a:rPr>
@@ -4992,7 +4992,7 @@
                 <a:solidFill>
                   <a:srgbClr val="2B2E3C"/>
                 </a:solidFill>
-                <a:latin typeface="Roboto" pitchFamily="34" charset="0"/>
+                <a:latin typeface="Calibri" pitchFamily="34" charset="0"/>
                 <a:ea typeface="Roboto" pitchFamily="34" charset="-122"/>
                 <a:cs typeface="Roboto" pitchFamily="34" charset="-120"/>
               </a:rPr>
@@ -5060,7 +5060,7 @@
                 <a:solidFill>
                   <a:srgbClr val="2B2E3C"/>
                 </a:solidFill>
-                <a:latin typeface="Roboto" pitchFamily="34" charset="0"/>
+                <a:latin typeface="Calibri" pitchFamily="34" charset="0"/>
                 <a:ea typeface="Roboto" pitchFamily="34" charset="-122"/>
                 <a:cs typeface="Roboto" pitchFamily="34" charset="-120"/>
               </a:rPr>
@@ -5085,7 +5085,7 @@
             <a:avLst/>
           </a:prstGeom>
           <a:solidFill>
-            <a:srgbClr val="F9FAFD"/>
+            <a:srgbClr val="FFFFFF"/>
           </a:solidFill>
           <a:ln w="12700">
             <a:solidFill>
@@ -5128,7 +5128,7 @@
                 <a:solidFill>
                   <a:srgbClr val="2B2E3C"/>
                 </a:solidFill>
-                <a:latin typeface="Roboto" pitchFamily="34" charset="0"/>
+                <a:latin typeface="Calibri" pitchFamily="34" charset="0"/>
                 <a:ea typeface="Roboto" pitchFamily="34" charset="-122"/>
                 <a:cs typeface="Roboto" pitchFamily="34" charset="-120"/>
               </a:rPr>
@@ -5153,7 +5153,7 @@
             <a:avLst/>
           </a:prstGeom>
           <a:solidFill>
-            <a:srgbClr val="F9FAFD"/>
+            <a:srgbClr val="FFFFFF"/>
           </a:solidFill>
           <a:ln w="12700">
             <a:solidFill>
@@ -5196,7 +5196,7 @@
                 <a:solidFill>
                   <a:srgbClr val="2B2E3C"/>
                 </a:solidFill>
-                <a:latin typeface="Roboto" pitchFamily="34" charset="0"/>
+                <a:latin typeface="Calibri" pitchFamily="34" charset="0"/>
                 <a:ea typeface="Roboto" pitchFamily="34" charset="-122"/>
                 <a:cs typeface="Roboto" pitchFamily="34" charset="-120"/>
               </a:rPr>
@@ -5221,7 +5221,7 @@
             <a:avLst/>
           </a:prstGeom>
           <a:solidFill>
-            <a:srgbClr val="F9FAFD"/>
+            <a:srgbClr val="FFFFFF"/>
           </a:solidFill>
           <a:ln w="12700">
             <a:solidFill>
@@ -5264,7 +5264,7 @@
                 <a:solidFill>
                   <a:srgbClr val="2B2E3C"/>
                 </a:solidFill>
-                <a:latin typeface="Roboto" pitchFamily="34" charset="0"/>
+                <a:latin typeface="Calibri" pitchFamily="34" charset="0"/>
                 <a:ea typeface="Roboto" pitchFamily="34" charset="-122"/>
                 <a:cs typeface="Roboto" pitchFamily="34" charset="-120"/>
               </a:rPr>
@@ -5289,7 +5289,7 @@
             <a:avLst/>
           </a:prstGeom>
           <a:solidFill>
-            <a:srgbClr val="F9FAFD"/>
+            <a:srgbClr val="FFFFFF"/>
           </a:solidFill>
           <a:ln w="12700">
             <a:solidFill>
@@ -5332,7 +5332,7 @@
                 <a:solidFill>
                   <a:srgbClr val="2B2E3C"/>
                 </a:solidFill>
-                <a:latin typeface="Roboto" pitchFamily="34" charset="0"/>
+                <a:latin typeface="Calibri" pitchFamily="34" charset="0"/>
                 <a:ea typeface="Roboto" pitchFamily="34" charset="-122"/>
                 <a:cs typeface="Roboto" pitchFamily="34" charset="-120"/>
               </a:rPr>
@@ -5357,7 +5357,7 @@
             <a:avLst/>
           </a:prstGeom>
           <a:solidFill>
-            <a:srgbClr val="F9FAFD"/>
+            <a:srgbClr val="FFFFFF"/>
           </a:solidFill>
           <a:ln w="12700">
             <a:solidFill>
@@ -5400,7 +5400,7 @@
                 <a:solidFill>
                   <a:srgbClr val="2B2E3C"/>
                 </a:solidFill>
-                <a:latin typeface="Roboto" pitchFamily="34" charset="0"/>
+                <a:latin typeface="Calibri" pitchFamily="34" charset="0"/>
                 <a:ea typeface="Roboto" pitchFamily="34" charset="-122"/>
                 <a:cs typeface="Roboto" pitchFamily="34" charset="-120"/>
               </a:rPr>
@@ -5466,9 +5466,9 @@
             <a:r>
               <a:rPr lang="en-US" sz="812" b="1" dirty="0">
                 <a:solidFill>
-                  <a:srgbClr val="FFFFFF"/>
-                </a:solidFill>
-                <a:latin typeface="Bitter" pitchFamily="34" charset="0"/>
+                  <a:srgbClr val="2B2E3C"/>
+                </a:solidFill>
+                <a:latin typeface="Calibri" pitchFamily="34" charset="0"/>
                 <a:ea typeface="Bitter" pitchFamily="34" charset="-122"/>
                 <a:cs typeface="Bitter" pitchFamily="34" charset="-120"/>
               </a:rPr>
@@ -5507,7 +5507,7 @@
                 <a:solidFill>
                   <a:srgbClr val="2B2E3C"/>
                 </a:solidFill>
-                <a:latin typeface="Bitter" pitchFamily="34" charset="0"/>
+                <a:latin typeface="Calibri" pitchFamily="34" charset="0"/>
                 <a:ea typeface="Bitter" pitchFamily="34" charset="-122"/>
                 <a:cs typeface="Bitter" pitchFamily="34" charset="-120"/>
               </a:rPr>
@@ -5544,9 +5544,9 @@
             <a:r>
               <a:rPr lang="en-US" sz="687" dirty="0">
                 <a:solidFill>
-                  <a:srgbClr val="334155"/>
-                </a:solidFill>
-                <a:latin typeface="Roboto" pitchFamily="34" charset="0"/>
+                  <a:srgbClr val="2B2E3C"/>
+                </a:solidFill>
+                <a:latin typeface="Calibri" pitchFamily="34" charset="0"/>
                 <a:ea typeface="Roboto" pitchFamily="34" charset="-122"/>
                 <a:cs typeface="Roboto" pitchFamily="34" charset="-120"/>
               </a:rPr>
@@ -5612,9 +5612,9 @@
             <a:r>
               <a:rPr lang="en-US" sz="812" b="1" dirty="0">
                 <a:solidFill>
-                  <a:srgbClr val="FFFFFF"/>
-                </a:solidFill>
-                <a:latin typeface="Bitter" pitchFamily="34" charset="0"/>
+                  <a:srgbClr val="2B2E3C"/>
+                </a:solidFill>
+                <a:latin typeface="Calibri" pitchFamily="34" charset="0"/>
                 <a:ea typeface="Bitter" pitchFamily="34" charset="-122"/>
                 <a:cs typeface="Bitter" pitchFamily="34" charset="-120"/>
               </a:rPr>
@@ -5653,7 +5653,7 @@
                 <a:solidFill>
                   <a:srgbClr val="2B2E3C"/>
                 </a:solidFill>
-                <a:latin typeface="Bitter" pitchFamily="34" charset="0"/>
+                <a:latin typeface="Calibri" pitchFamily="34" charset="0"/>
                 <a:ea typeface="Bitter" pitchFamily="34" charset="-122"/>
                 <a:cs typeface="Bitter" pitchFamily="34" charset="-120"/>
               </a:rPr>
@@ -5690,9 +5690,9 @@
             <a:r>
               <a:rPr lang="en-US" sz="687" dirty="0">
                 <a:solidFill>
-                  <a:srgbClr val="334155"/>
-                </a:solidFill>
-                <a:latin typeface="Roboto" pitchFamily="34" charset="0"/>
+                  <a:srgbClr val="2B2E3C"/>
+                </a:solidFill>
+                <a:latin typeface="Calibri" pitchFamily="34" charset="0"/>
                 <a:ea typeface="Roboto" pitchFamily="34" charset="-122"/>
                 <a:cs typeface="Roboto" pitchFamily="34" charset="-120"/>
               </a:rPr>
@@ -5758,9 +5758,9 @@
             <a:r>
               <a:rPr lang="en-US" sz="812" b="1" dirty="0">
                 <a:solidFill>
-                  <a:srgbClr val="FFFFFF"/>
-                </a:solidFill>
-                <a:latin typeface="Bitter" pitchFamily="34" charset="0"/>
+                  <a:srgbClr val="2B2E3C"/>
+                </a:solidFill>
+                <a:latin typeface="Calibri" pitchFamily="34" charset="0"/>
                 <a:ea typeface="Bitter" pitchFamily="34" charset="-122"/>
                 <a:cs typeface="Bitter" pitchFamily="34" charset="-120"/>
               </a:rPr>
@@ -5799,7 +5799,7 @@
                 <a:solidFill>
                   <a:srgbClr val="2B2E3C"/>
                 </a:solidFill>
-                <a:latin typeface="Bitter" pitchFamily="34" charset="0"/>
+                <a:latin typeface="Calibri" pitchFamily="34" charset="0"/>
                 <a:ea typeface="Bitter" pitchFamily="34" charset="-122"/>
                 <a:cs typeface="Bitter" pitchFamily="34" charset="-120"/>
               </a:rPr>
@@ -5836,9 +5836,9 @@
             <a:r>
               <a:rPr lang="en-US" sz="687" dirty="0">
                 <a:solidFill>
-                  <a:srgbClr val="334155"/>
-                </a:solidFill>
-                <a:latin typeface="Roboto" pitchFamily="34" charset="0"/>
+                  <a:srgbClr val="2B2E3C"/>
+                </a:solidFill>
+                <a:latin typeface="Calibri" pitchFamily="34" charset="0"/>
                 <a:ea typeface="Roboto" pitchFamily="34" charset="-122"/>
                 <a:cs typeface="Roboto" pitchFamily="34" charset="-120"/>
               </a:rPr>
@@ -5875,9 +5875,9 @@
             <a:r>
               <a:rPr lang="en-US" sz="531" i="1" dirty="0">
                 <a:solidFill>
-                  <a:srgbClr val="64748B"/>
-                </a:solidFill>
-                <a:latin typeface="Open Sans" pitchFamily="34" charset="0"/>
+                  <a:srgbClr val="2B2E3C"/>
+                </a:solidFill>
+                <a:latin typeface="Calibri" pitchFamily="34" charset="0"/>
                 <a:ea typeface="Open Sans" pitchFamily="34" charset="-122"/>
                 <a:cs typeface="Open Sans" pitchFamily="34" charset="-120"/>
               </a:rPr>
@@ -5934,7 +5934,7 @@
             <a:avLst/>
           </a:prstGeom>
           <a:solidFill>
-            <a:srgbClr val="2C3F42"/>
+            <a:srgbClr val="FFF8F0"/>
           </a:solidFill>
           <a:ln w="12700">
             <a:solidFill>
@@ -5975,9 +5975,9 @@
             <a:r>
               <a:rPr lang="en-US" sz="531" b="1" spc="300" kern="0" dirty="0">
                 <a:solidFill>
-                  <a:srgbClr val="E2C8B5"/>
-                </a:solidFill>
-                <a:latin typeface="Open Sans" pitchFamily="34" charset="0"/>
+                  <a:srgbClr val="AF2C20"/>
+                </a:solidFill>
+                <a:latin typeface="Calibri" pitchFamily="34" charset="0"/>
                 <a:ea typeface="Open Sans" pitchFamily="34" charset="-122"/>
                 <a:cs typeface="Open Sans" pitchFamily="34" charset="-120"/>
               </a:rPr>
@@ -6014,9 +6014,9 @@
             <a:r>
               <a:rPr lang="en-US" sz="1500" b="1" dirty="0">
                 <a:solidFill>
-                  <a:srgbClr val="FFFFFF"/>
-                </a:solidFill>
-                <a:latin typeface="Bitter" pitchFamily="34" charset="0"/>
+                  <a:srgbClr val="2B2E3C"/>
+                </a:solidFill>
+                <a:latin typeface="Calibri" pitchFamily="34" charset="0"/>
                 <a:ea typeface="Bitter" pitchFamily="34" charset="-122"/>
                 <a:cs typeface="Bitter" pitchFamily="34" charset="-120"/>
               </a:rPr>
@@ -6070,7 +6070,7 @@
             <a:avLst/>
           </a:prstGeom>
           <a:solidFill>
-            <a:srgbClr val="2C3F42"/>
+            <a:srgbClr val="FFF8F0"/>
           </a:solidFill>
           <a:ln w="12700">
             <a:solidFill>
@@ -6111,9 +6111,9 @@
             <a:r>
               <a:rPr lang="en-US" sz="687" b="1" spc="100" kern="0" dirty="0">
                 <a:solidFill>
-                  <a:srgbClr val="E2C8B5"/>
-                </a:solidFill>
-                <a:latin typeface="Bitter" pitchFamily="34" charset="0"/>
+                  <a:srgbClr val="AF2C20"/>
+                </a:solidFill>
+                <a:latin typeface="Calibri" pitchFamily="34" charset="0"/>
                 <a:ea typeface="Bitter" pitchFamily="34" charset="-122"/>
                 <a:cs typeface="Bitter" pitchFamily="34" charset="-120"/>
               </a:rPr>
@@ -6138,7 +6138,7 @@
             <a:avLst/>
           </a:prstGeom>
           <a:solidFill>
-            <a:srgbClr val="2C3F42"/>
+            <a:srgbClr val="FFF8F0"/>
           </a:solidFill>
           <a:ln w="12700">
             <a:solidFill>
@@ -6179,9 +6179,9 @@
             <a:r>
               <a:rPr lang="en-US" sz="562" b="1" dirty="0">
                 <a:solidFill>
-                  <a:srgbClr val="E2C8B5"/>
-                </a:solidFill>
-                <a:latin typeface="Open Sans" pitchFamily="34" charset="0"/>
+                  <a:srgbClr val="AF2C20"/>
+                </a:solidFill>
+                <a:latin typeface="Calibri" pitchFamily="34" charset="0"/>
                 <a:ea typeface="Open Sans" pitchFamily="34" charset="-122"/>
                 <a:cs typeface="Open Sans" pitchFamily="34" charset="-120"/>
               </a:rPr>
@@ -6218,9 +6218,9 @@
             <a:r>
               <a:rPr lang="en-US" sz="718" i="1" dirty="0">
                 <a:solidFill>
-                  <a:srgbClr val="FFFFFF"/>
-                </a:solidFill>
-                <a:latin typeface="Roboto" pitchFamily="34" charset="0"/>
+                  <a:srgbClr val="2B2E3C"/>
+                </a:solidFill>
+                <a:latin typeface="Calibri" pitchFamily="34" charset="0"/>
                 <a:ea typeface="Roboto" pitchFamily="34" charset="-122"/>
                 <a:cs typeface="Roboto" pitchFamily="34" charset="-120"/>
               </a:rPr>
@@ -6315,9 +6315,9 @@
             <a:r>
               <a:rPr lang="en-US" sz="812" b="1" dirty="0">
                 <a:solidFill>
-                  <a:srgbClr val="FFFFFF"/>
-                </a:solidFill>
-                <a:latin typeface="Bitter" pitchFamily="34" charset="0"/>
+                  <a:srgbClr val="2B2E3C"/>
+                </a:solidFill>
+                <a:latin typeface="Calibri" pitchFamily="34" charset="0"/>
                 <a:ea typeface="Bitter" pitchFamily="34" charset="-122"/>
                 <a:cs typeface="Bitter" pitchFamily="34" charset="-120"/>
               </a:rPr>
@@ -6356,7 +6356,7 @@
                 <a:solidFill>
                   <a:srgbClr val="2B2E3C"/>
                 </a:solidFill>
-                <a:latin typeface="Roboto" pitchFamily="34" charset="0"/>
+                <a:latin typeface="Calibri" pitchFamily="34" charset="0"/>
                 <a:ea typeface="Roboto" pitchFamily="34" charset="-122"/>
                 <a:cs typeface="Roboto" pitchFamily="34" charset="-120"/>
               </a:rPr>
@@ -6379,7 +6379,7 @@
                 <a:solidFill>
                   <a:srgbClr val="2B2E3C"/>
                 </a:solidFill>
-                <a:latin typeface="Roboto" pitchFamily="34" charset="0"/>
+                <a:latin typeface="Calibri" pitchFamily="34" charset="0"/>
                 <a:ea typeface="Roboto" pitchFamily="34" charset="-122"/>
                 <a:cs typeface="Roboto" pitchFamily="34" charset="-120"/>
               </a:rPr>
@@ -6474,9 +6474,9 @@
             <a:r>
               <a:rPr lang="en-US" sz="812" b="1" dirty="0">
                 <a:solidFill>
-                  <a:srgbClr val="FFFFFF"/>
-                </a:solidFill>
-                <a:latin typeface="Bitter" pitchFamily="34" charset="0"/>
+                  <a:srgbClr val="2B2E3C"/>
+                </a:solidFill>
+                <a:latin typeface="Calibri" pitchFamily="34" charset="0"/>
                 <a:ea typeface="Bitter" pitchFamily="34" charset="-122"/>
                 <a:cs typeface="Bitter" pitchFamily="34" charset="-120"/>
               </a:rPr>
@@ -6515,7 +6515,7 @@
                 <a:solidFill>
                   <a:srgbClr val="2B2E3C"/>
                 </a:solidFill>
-                <a:latin typeface="Roboto" pitchFamily="34" charset="0"/>
+                <a:latin typeface="Calibri" pitchFamily="34" charset="0"/>
                 <a:ea typeface="Roboto" pitchFamily="34" charset="-122"/>
                 <a:cs typeface="Roboto" pitchFamily="34" charset="-120"/>
               </a:rPr>
@@ -6610,9 +6610,9 @@
             <a:r>
               <a:rPr lang="en-US" sz="812" b="1" dirty="0">
                 <a:solidFill>
-                  <a:srgbClr val="FFFFFF"/>
-                </a:solidFill>
-                <a:latin typeface="Bitter" pitchFamily="34" charset="0"/>
+                  <a:srgbClr val="2B2E3C"/>
+                </a:solidFill>
+                <a:latin typeface="Calibri" pitchFamily="34" charset="0"/>
                 <a:ea typeface="Bitter" pitchFamily="34" charset="-122"/>
                 <a:cs typeface="Bitter" pitchFamily="34" charset="-120"/>
               </a:rPr>
@@ -6651,7 +6651,7 @@
                 <a:solidFill>
                   <a:srgbClr val="2B2E3C"/>
                 </a:solidFill>
-                <a:latin typeface="Roboto" pitchFamily="34" charset="0"/>
+                <a:latin typeface="Calibri" pitchFamily="34" charset="0"/>
                 <a:ea typeface="Roboto" pitchFamily="34" charset="-122"/>
                 <a:cs typeface="Roboto" pitchFamily="34" charset="-120"/>
               </a:rPr>
@@ -6705,7 +6705,7 @@
             <a:avLst/>
           </a:prstGeom>
           <a:solidFill>
-            <a:srgbClr val="2C3F42"/>
+            <a:srgbClr val="FFF8F0"/>
           </a:solidFill>
           <a:ln w="12700">
             <a:solidFill>
@@ -6746,9 +6746,9 @@
             <a:r>
               <a:rPr lang="en-US" sz="687" b="1" spc="100" kern="0" dirty="0">
                 <a:solidFill>
-                  <a:srgbClr val="E2C8B5"/>
-                </a:solidFill>
-                <a:latin typeface="Bitter" pitchFamily="34" charset="0"/>
+                  <a:srgbClr val="AF2C20"/>
+                </a:solidFill>
+                <a:latin typeface="Calibri" pitchFamily="34" charset="0"/>
                 <a:ea typeface="Bitter" pitchFamily="34" charset="-122"/>
                 <a:cs typeface="Bitter" pitchFamily="34" charset="-120"/>
               </a:rPr>
@@ -6773,7 +6773,7 @@
             <a:avLst/>
           </a:prstGeom>
           <a:solidFill>
-            <a:srgbClr val="2C3F42"/>
+            <a:srgbClr val="FFF8F0"/>
           </a:solidFill>
           <a:ln w="12700">
             <a:solidFill>
@@ -6814,9 +6814,9 @@
             <a:r>
               <a:rPr lang="en-US" sz="656" i="1" dirty="0">
                 <a:solidFill>
-                  <a:srgbClr val="FFFFFF"/>
-                </a:solidFill>
-                <a:latin typeface="Roboto" pitchFamily="34" charset="0"/>
+                  <a:srgbClr val="2B2E3C"/>
+                </a:solidFill>
+                <a:latin typeface="Calibri" pitchFamily="34" charset="0"/>
                 <a:ea typeface="Roboto" pitchFamily="34" charset="-122"/>
                 <a:cs typeface="Roboto" pitchFamily="34" charset="-120"/>
               </a:rPr>
@@ -6841,7 +6841,7 @@
             <a:avLst/>
           </a:prstGeom>
           <a:solidFill>
-            <a:srgbClr val="2C3F42"/>
+            <a:srgbClr val="FFF8F0"/>
           </a:solidFill>
           <a:ln w="12700">
             <a:solidFill>
@@ -6882,9 +6882,9 @@
             <a:r>
               <a:rPr lang="en-US" sz="562" b="1" dirty="0">
                 <a:solidFill>
-                  <a:srgbClr val="FFFFFF"/>
-                </a:solidFill>
-                <a:latin typeface="Bitter" pitchFamily="34" charset="0"/>
+                  <a:srgbClr val="2B2E3C"/>
+                </a:solidFill>
+                <a:latin typeface="Calibri" pitchFamily="34" charset="0"/>
                 <a:ea typeface="Bitter" pitchFamily="34" charset="-122"/>
                 <a:cs typeface="Bitter" pitchFamily="34" charset="-120"/>
               </a:rPr>
@@ -6899,9 +6899,9 @@
             <a:r>
               <a:rPr lang="en-US" sz="562" b="1" dirty="0">
                 <a:solidFill>
-                  <a:srgbClr val="FFFFFF"/>
-                </a:solidFill>
-                <a:latin typeface="Bitter" pitchFamily="34" charset="0"/>
+                  <a:srgbClr val="2B2E3C"/>
+                </a:solidFill>
+                <a:latin typeface="Calibri" pitchFamily="34" charset="0"/>
                 <a:ea typeface="Bitter" pitchFamily="34" charset="-122"/>
                 <a:cs typeface="Bitter" pitchFamily="34" charset="-120"/>
               </a:rPr>
@@ -6955,7 +6955,7 @@
             <a:avLst/>
           </a:prstGeom>
           <a:solidFill>
-            <a:srgbClr val="2B2E3C"/>
+            <a:srgbClr val="FFF8F0"/>
           </a:solidFill>
           <a:ln w="12700">
             <a:solidFill>
@@ -6996,9 +6996,9 @@
             <a:r>
               <a:rPr lang="en-US" sz="468" b="1" dirty="0">
                 <a:solidFill>
-                  <a:srgbClr val="FFFFFF"/>
-                </a:solidFill>
-                <a:latin typeface="Bitter" pitchFamily="34" charset="0"/>
+                  <a:srgbClr val="2B2E3C"/>
+                </a:solidFill>
+                <a:latin typeface="Calibri" pitchFamily="34" charset="0"/>
                 <a:ea typeface="Bitter" pitchFamily="34" charset="-122"/>
                 <a:cs typeface="Bitter" pitchFamily="34" charset="-120"/>
               </a:rPr>
@@ -7023,7 +7023,7 @@
             <a:avLst/>
           </a:prstGeom>
           <a:solidFill>
-            <a:srgbClr val="2C3F42"/>
+            <a:srgbClr val="FFF8F0"/>
           </a:solidFill>
           <a:ln w="12700">
             <a:solidFill>
@@ -7064,9 +7064,9 @@
             <a:r>
               <a:rPr lang="en-US" sz="562" b="1" dirty="0">
                 <a:solidFill>
-                  <a:srgbClr val="FFFFFF"/>
-                </a:solidFill>
-                <a:latin typeface="Bitter" pitchFamily="34" charset="0"/>
+                  <a:srgbClr val="2B2E3C"/>
+                </a:solidFill>
+                <a:latin typeface="Calibri" pitchFamily="34" charset="0"/>
                 <a:ea typeface="Bitter" pitchFamily="34" charset="-122"/>
                 <a:cs typeface="Bitter" pitchFamily="34" charset="-120"/>
               </a:rPr>
@@ -7081,9 +7081,9 @@
             <a:r>
               <a:rPr lang="en-US" sz="562" b="1" dirty="0">
                 <a:solidFill>
-                  <a:srgbClr val="FFFFFF"/>
-                </a:solidFill>
-                <a:latin typeface="Bitter" pitchFamily="34" charset="0"/>
+                  <a:srgbClr val="2B2E3C"/>
+                </a:solidFill>
+                <a:latin typeface="Calibri" pitchFamily="34" charset="0"/>
                 <a:ea typeface="Bitter" pitchFamily="34" charset="-122"/>
                 <a:cs typeface="Bitter" pitchFamily="34" charset="-120"/>
               </a:rPr>
@@ -7137,7 +7137,7 @@
             <a:avLst/>
           </a:prstGeom>
           <a:solidFill>
-            <a:srgbClr val="2B2E3C"/>
+            <a:srgbClr val="FFF8F0"/>
           </a:solidFill>
           <a:ln w="12700">
             <a:solidFill>
@@ -7178,9 +7178,9 @@
             <a:r>
               <a:rPr lang="en-US" sz="468" b="1" dirty="0">
                 <a:solidFill>
-                  <a:srgbClr val="FFFFFF"/>
-                </a:solidFill>
-                <a:latin typeface="Bitter" pitchFamily="34" charset="0"/>
+                  <a:srgbClr val="2B2E3C"/>
+                </a:solidFill>
+                <a:latin typeface="Calibri" pitchFamily="34" charset="0"/>
                 <a:ea typeface="Bitter" pitchFamily="34" charset="-122"/>
                 <a:cs typeface="Bitter" pitchFamily="34" charset="-120"/>
               </a:rPr>
@@ -7205,7 +7205,7 @@
             <a:avLst/>
           </a:prstGeom>
           <a:solidFill>
-            <a:srgbClr val="2C3F42"/>
+            <a:srgbClr val="FFF8F0"/>
           </a:solidFill>
           <a:ln w="12700">
             <a:solidFill>
@@ -7246,9 +7246,9 @@
             <a:r>
               <a:rPr lang="en-US" sz="562" b="1" dirty="0">
                 <a:solidFill>
-                  <a:srgbClr val="FFFFFF"/>
-                </a:solidFill>
-                <a:latin typeface="Bitter" pitchFamily="34" charset="0"/>
+                  <a:srgbClr val="2B2E3C"/>
+                </a:solidFill>
+                <a:latin typeface="Calibri" pitchFamily="34" charset="0"/>
                 <a:ea typeface="Bitter" pitchFamily="34" charset="-122"/>
                 <a:cs typeface="Bitter" pitchFamily="34" charset="-120"/>
               </a:rPr>
@@ -7263,9 +7263,9 @@
             <a:r>
               <a:rPr lang="en-US" sz="562" b="1" dirty="0">
                 <a:solidFill>
-                  <a:srgbClr val="FFFFFF"/>
-                </a:solidFill>
-                <a:latin typeface="Bitter" pitchFamily="34" charset="0"/>
+                  <a:srgbClr val="2B2E3C"/>
+                </a:solidFill>
+                <a:latin typeface="Calibri" pitchFamily="34" charset="0"/>
                 <a:ea typeface="Bitter" pitchFamily="34" charset="-122"/>
                 <a:cs typeface="Bitter" pitchFamily="34" charset="-120"/>
               </a:rPr>
@@ -7319,7 +7319,7 @@
             <a:avLst/>
           </a:prstGeom>
           <a:solidFill>
-            <a:srgbClr val="2B2E3C"/>
+            <a:srgbClr val="FFF8F0"/>
           </a:solidFill>
           <a:ln w="12700">
             <a:solidFill>
@@ -7360,9 +7360,9 @@
             <a:r>
               <a:rPr lang="en-US" sz="468" b="1" dirty="0">
                 <a:solidFill>
-                  <a:srgbClr val="FFFFFF"/>
-                </a:solidFill>
-                <a:latin typeface="Bitter" pitchFamily="34" charset="0"/>
+                  <a:srgbClr val="2B2E3C"/>
+                </a:solidFill>
+                <a:latin typeface="Calibri" pitchFamily="34" charset="0"/>
                 <a:ea typeface="Bitter" pitchFamily="34" charset="-122"/>
                 <a:cs typeface="Bitter" pitchFamily="34" charset="-120"/>
               </a:rPr>
@@ -7387,7 +7387,7 @@
             <a:avLst/>
           </a:prstGeom>
           <a:solidFill>
-            <a:srgbClr val="2C3F42"/>
+            <a:srgbClr val="FFF8F0"/>
           </a:solidFill>
           <a:ln w="12700">
             <a:solidFill>
@@ -7428,9 +7428,9 @@
             <a:r>
               <a:rPr lang="en-US" sz="562" b="1" dirty="0">
                 <a:solidFill>
-                  <a:srgbClr val="FFFFFF"/>
-                </a:solidFill>
-                <a:latin typeface="Bitter" pitchFamily="34" charset="0"/>
+                  <a:srgbClr val="2B2E3C"/>
+                </a:solidFill>
+                <a:latin typeface="Calibri" pitchFamily="34" charset="0"/>
                 <a:ea typeface="Bitter" pitchFamily="34" charset="-122"/>
                 <a:cs typeface="Bitter" pitchFamily="34" charset="-120"/>
               </a:rPr>
@@ -7445,9 +7445,9 @@
             <a:r>
               <a:rPr lang="en-US" sz="562" b="1" dirty="0">
                 <a:solidFill>
-                  <a:srgbClr val="FFFFFF"/>
-                </a:solidFill>
-                <a:latin typeface="Bitter" pitchFamily="34" charset="0"/>
+                  <a:srgbClr val="2B2E3C"/>
+                </a:solidFill>
+                <a:latin typeface="Calibri" pitchFamily="34" charset="0"/>
                 <a:ea typeface="Bitter" pitchFamily="34" charset="-122"/>
                 <a:cs typeface="Bitter" pitchFamily="34" charset="-120"/>
               </a:rPr>
@@ -7513,9 +7513,9 @@
             <a:r>
               <a:rPr lang="en-US" sz="406" b="1" dirty="0">
                 <a:solidFill>
-                  <a:srgbClr val="FFFFFF"/>
-                </a:solidFill>
-                <a:latin typeface="Bitter" pitchFamily="34" charset="0"/>
+                  <a:srgbClr val="2B2E3C"/>
+                </a:solidFill>
+                <a:latin typeface="Calibri" pitchFamily="34" charset="0"/>
                 <a:ea typeface="Bitter" pitchFamily="34" charset="-122"/>
                 <a:cs typeface="Bitter" pitchFamily="34" charset="-120"/>
               </a:rPr>
@@ -7530,9 +7530,9 @@
             <a:r>
               <a:rPr lang="en-US" sz="406" b="1" dirty="0">
                 <a:solidFill>
-                  <a:srgbClr val="FFFFFF"/>
-                </a:solidFill>
-                <a:latin typeface="Bitter" pitchFamily="34" charset="0"/>
+                  <a:srgbClr val="2B2E3C"/>
+                </a:solidFill>
+                <a:latin typeface="Calibri" pitchFamily="34" charset="0"/>
                 <a:ea typeface="Bitter" pitchFamily="34" charset="-122"/>
                 <a:cs typeface="Bitter" pitchFamily="34" charset="-120"/>
               </a:rPr>
@@ -7557,7 +7557,7 @@
             <a:avLst/>
           </a:prstGeom>
           <a:solidFill>
-            <a:srgbClr val="2B2E3C"/>
+            <a:srgbClr val="FFF8F0"/>
           </a:solidFill>
           <a:ln w="12700">
             <a:solidFill>
@@ -7598,9 +7598,9 @@
             <a:r>
               <a:rPr lang="en-US" sz="468" b="1" dirty="0">
                 <a:solidFill>
-                  <a:srgbClr val="FFFFFF"/>
-                </a:solidFill>
-                <a:latin typeface="Bitter" pitchFamily="34" charset="0"/>
+                  <a:srgbClr val="2B2E3C"/>
+                </a:solidFill>
+                <a:latin typeface="Calibri" pitchFamily="34" charset="0"/>
                 <a:ea typeface="Bitter" pitchFamily="34" charset="-122"/>
                 <a:cs typeface="Bitter" pitchFamily="34" charset="-120"/>
               </a:rPr>
@@ -7726,7 +7726,7 @@
                 <a:solidFill>
                   <a:srgbClr val="2B2E3C"/>
                 </a:solidFill>
-                <a:latin typeface="Bitter" pitchFamily="34" charset="0"/>
+                <a:latin typeface="Calibri" pitchFamily="34" charset="0"/>
                 <a:ea typeface="Bitter" pitchFamily="34" charset="-122"/>
                 <a:cs typeface="Bitter" pitchFamily="34" charset="-120"/>
               </a:rPr>
@@ -7763,9 +7763,9 @@
             <a:r>
               <a:rPr lang="en-US" sz="656" dirty="0">
                 <a:solidFill>
-                  <a:srgbClr val="334155"/>
-                </a:solidFill>
-                <a:latin typeface="Roboto" pitchFamily="34" charset="0"/>
+                  <a:srgbClr val="2B2E3C"/>
+                </a:solidFill>
+                <a:latin typeface="Calibri" pitchFamily="34" charset="0"/>
                 <a:ea typeface="Roboto" pitchFamily="34" charset="-122"/>
                 <a:cs typeface="Roboto" pitchFamily="34" charset="-120"/>
               </a:rPr>
@@ -7862,7 +7862,7 @@
                 <a:solidFill>
                   <a:srgbClr val="2B2E3C"/>
                 </a:solidFill>
-                <a:latin typeface="Bitter" pitchFamily="34" charset="0"/>
+                <a:latin typeface="Calibri" pitchFamily="34" charset="0"/>
                 <a:ea typeface="Bitter" pitchFamily="34" charset="-122"/>
                 <a:cs typeface="Bitter" pitchFamily="34" charset="-120"/>
               </a:rPr>
@@ -7899,9 +7899,9 @@
             <a:r>
               <a:rPr lang="en-US" sz="656" dirty="0">
                 <a:solidFill>
-                  <a:srgbClr val="334155"/>
-                </a:solidFill>
-                <a:latin typeface="Roboto" pitchFamily="34" charset="0"/>
+                  <a:srgbClr val="2B2E3C"/>
+                </a:solidFill>
+                <a:latin typeface="Calibri" pitchFamily="34" charset="0"/>
                 <a:ea typeface="Roboto" pitchFamily="34" charset="-122"/>
                 <a:cs typeface="Roboto" pitchFamily="34" charset="-120"/>
               </a:rPr>
@@ -7998,7 +7998,7 @@
                 <a:solidFill>
                   <a:srgbClr val="2B2E3C"/>
                 </a:solidFill>
-                <a:latin typeface="Bitter" pitchFamily="34" charset="0"/>
+                <a:latin typeface="Calibri" pitchFamily="34" charset="0"/>
                 <a:ea typeface="Bitter" pitchFamily="34" charset="-122"/>
                 <a:cs typeface="Bitter" pitchFamily="34" charset="-120"/>
               </a:rPr>
@@ -8035,9 +8035,9 @@
             <a:r>
               <a:rPr lang="en-US" sz="656" dirty="0">
                 <a:solidFill>
-                  <a:srgbClr val="334155"/>
-                </a:solidFill>
-                <a:latin typeface="Roboto" pitchFamily="34" charset="0"/>
+                  <a:srgbClr val="2B2E3C"/>
+                </a:solidFill>
+                <a:latin typeface="Calibri" pitchFamily="34" charset="0"/>
                 <a:ea typeface="Roboto" pitchFamily="34" charset="-122"/>
                 <a:cs typeface="Roboto" pitchFamily="34" charset="-120"/>
               </a:rPr>
@@ -8074,9 +8074,9 @@
             <a:r>
               <a:rPr lang="en-US" sz="531" i="1" dirty="0">
                 <a:solidFill>
-                  <a:srgbClr val="64748B"/>
-                </a:solidFill>
-                <a:latin typeface="Open Sans" pitchFamily="34" charset="0"/>
+                  <a:srgbClr val="2B2E3C"/>
+                </a:solidFill>
+                <a:latin typeface="Calibri" pitchFamily="34" charset="0"/>
                 <a:ea typeface="Open Sans" pitchFamily="34" charset="-122"/>
                 <a:cs typeface="Open Sans" pitchFamily="34" charset="-120"/>
               </a:rPr>
@@ -8133,7 +8133,7 @@
             <a:avLst/>
           </a:prstGeom>
           <a:solidFill>
-            <a:srgbClr val="2C3F42"/>
+            <a:srgbClr val="FFF8F0"/>
           </a:solidFill>
           <a:ln w="12700">
             <a:solidFill>
@@ -8174,9 +8174,9 @@
             <a:r>
               <a:rPr lang="en-US" sz="531" b="1" spc="300" kern="0" dirty="0">
                 <a:solidFill>
-                  <a:srgbClr val="E2C8B5"/>
-                </a:solidFill>
-                <a:latin typeface="Open Sans" pitchFamily="34" charset="0"/>
+                  <a:srgbClr val="AF2C20"/>
+                </a:solidFill>
+                <a:latin typeface="Calibri" pitchFamily="34" charset="0"/>
                 <a:ea typeface="Open Sans" pitchFamily="34" charset="-122"/>
                 <a:cs typeface="Open Sans" pitchFamily="34" charset="-120"/>
               </a:rPr>
@@ -8213,9 +8213,9 @@
             <a:r>
               <a:rPr lang="en-US" sz="1500" b="1" dirty="0">
                 <a:solidFill>
-                  <a:srgbClr val="FFFFFF"/>
-                </a:solidFill>
-                <a:latin typeface="Bitter" pitchFamily="34" charset="0"/>
+                  <a:srgbClr val="2B2E3C"/>
+                </a:solidFill>
+                <a:latin typeface="Calibri" pitchFamily="34" charset="0"/>
                 <a:ea typeface="Bitter" pitchFamily="34" charset="-122"/>
                 <a:cs typeface="Bitter" pitchFamily="34" charset="-120"/>
               </a:rPr>
@@ -8240,7 +8240,7 @@
             <a:avLst/>
           </a:prstGeom>
           <a:solidFill>
-            <a:srgbClr val="2C3F42"/>
+            <a:srgbClr val="FFF8F0"/>
           </a:solidFill>
           <a:ln w="12700">
             <a:solidFill>
@@ -8281,9 +8281,9 @@
             <a:r>
               <a:rPr lang="en-US" sz="687" b="1" dirty="0">
                 <a:solidFill>
-                  <a:srgbClr val="FFFFFF"/>
-                </a:solidFill>
-                <a:latin typeface="Bitter" pitchFamily="34" charset="0"/>
+                  <a:srgbClr val="2B2E3C"/>
+                </a:solidFill>
+                <a:latin typeface="Calibri" pitchFamily="34" charset="0"/>
                 <a:ea typeface="Bitter" pitchFamily="34" charset="-122"/>
                 <a:cs typeface="Bitter" pitchFamily="34" charset="-120"/>
               </a:rPr>
@@ -8308,7 +8308,7 @@
             <a:avLst/>
           </a:prstGeom>
           <a:solidFill>
-            <a:srgbClr val="2C3F42"/>
+            <a:srgbClr val="FFF8F0"/>
           </a:solidFill>
           <a:ln w="12700">
             <a:solidFill>
@@ -8349,9 +8349,9 @@
             <a:r>
               <a:rPr lang="en-US" sz="687" b="1" dirty="0">
                 <a:solidFill>
-                  <a:srgbClr val="FFFFFF"/>
-                </a:solidFill>
-                <a:latin typeface="Bitter" pitchFamily="34" charset="0"/>
+                  <a:srgbClr val="2B2E3C"/>
+                </a:solidFill>
+                <a:latin typeface="Calibri" pitchFamily="34" charset="0"/>
                 <a:ea typeface="Bitter" pitchFamily="34" charset="-122"/>
                 <a:cs typeface="Bitter" pitchFamily="34" charset="-120"/>
               </a:rPr>
@@ -8376,7 +8376,7 @@
             <a:avLst/>
           </a:prstGeom>
           <a:solidFill>
-            <a:srgbClr val="2C3F42"/>
+            <a:srgbClr val="FFF8F0"/>
           </a:solidFill>
           <a:ln w="12700">
             <a:solidFill>
@@ -8417,9 +8417,9 @@
             <a:r>
               <a:rPr lang="en-US" sz="687" b="1" dirty="0">
                 <a:solidFill>
-                  <a:srgbClr val="FFFFFF"/>
-                </a:solidFill>
-                <a:latin typeface="Bitter" pitchFamily="34" charset="0"/>
+                  <a:srgbClr val="2B2E3C"/>
+                </a:solidFill>
+                <a:latin typeface="Calibri" pitchFamily="34" charset="0"/>
                 <a:ea typeface="Bitter" pitchFamily="34" charset="-122"/>
                 <a:cs typeface="Bitter" pitchFamily="34" charset="-120"/>
               </a:rPr>
@@ -8444,7 +8444,7 @@
             <a:avLst/>
           </a:prstGeom>
           <a:solidFill>
-            <a:srgbClr val="2C3F42"/>
+            <a:srgbClr val="FFF8F0"/>
           </a:solidFill>
           <a:ln w="12700">
             <a:solidFill>
@@ -8485,9 +8485,9 @@
             <a:r>
               <a:rPr lang="en-US" sz="687" b="1" dirty="0">
                 <a:solidFill>
-                  <a:srgbClr val="FFFFFF"/>
-                </a:solidFill>
-                <a:latin typeface="Bitter" pitchFamily="34" charset="0"/>
+                  <a:srgbClr val="2B2E3C"/>
+                </a:solidFill>
+                <a:latin typeface="Calibri" pitchFamily="34" charset="0"/>
                 <a:ea typeface="Bitter" pitchFamily="34" charset="-122"/>
                 <a:cs typeface="Bitter" pitchFamily="34" charset="-120"/>
               </a:rPr>
@@ -8512,7 +8512,7 @@
             <a:avLst/>
           </a:prstGeom>
           <a:solidFill>
-            <a:srgbClr val="2C3F42"/>
+            <a:srgbClr val="FFF8F0"/>
           </a:solidFill>
           <a:ln w="12700">
             <a:solidFill>
@@ -8553,9 +8553,9 @@
             <a:r>
               <a:rPr lang="en-US" sz="687" b="1" dirty="0">
                 <a:solidFill>
-                  <a:srgbClr val="FFFFFF"/>
-                </a:solidFill>
-                <a:latin typeface="Bitter" pitchFamily="34" charset="0"/>
+                  <a:srgbClr val="2B2E3C"/>
+                </a:solidFill>
+                <a:latin typeface="Calibri" pitchFamily="34" charset="0"/>
                 <a:ea typeface="Bitter" pitchFamily="34" charset="-122"/>
                 <a:cs typeface="Bitter" pitchFamily="34" charset="-120"/>
               </a:rPr>
@@ -8766,9 +8766,9 @@
             <a:r>
               <a:rPr lang="en-US" sz="750" b="1" dirty="0">
                 <a:solidFill>
-                  <a:srgbClr val="FFFFFF"/>
-                </a:solidFill>
-                <a:latin typeface="Bitter" pitchFamily="34" charset="0"/>
+                  <a:srgbClr val="2B2E3C"/>
+                </a:solidFill>
+                <a:latin typeface="Calibri" pitchFamily="34" charset="0"/>
                 <a:ea typeface="Bitter" pitchFamily="34" charset="-122"/>
                 <a:cs typeface="Bitter" pitchFamily="34" charset="-120"/>
               </a:rPr>
@@ -8807,7 +8807,7 @@
                 <a:solidFill>
                   <a:srgbClr val="2B2E3C"/>
                 </a:solidFill>
-                <a:latin typeface="Bitter" pitchFamily="34" charset="0"/>
+                <a:latin typeface="Calibri" pitchFamily="34" charset="0"/>
                 <a:ea typeface="Bitter" pitchFamily="34" charset="-122"/>
                 <a:cs typeface="Bitter" pitchFamily="34" charset="-120"/>
               </a:rPr>
@@ -8844,9 +8844,9 @@
             <a:r>
               <a:rPr lang="en-US" sz="625" dirty="0">
                 <a:solidFill>
-                  <a:srgbClr val="334155"/>
-                </a:solidFill>
-                <a:latin typeface="Roboto" pitchFamily="34" charset="0"/>
+                  <a:srgbClr val="2B2E3C"/>
+                </a:solidFill>
+                <a:latin typeface="Calibri" pitchFamily="34" charset="0"/>
                 <a:ea typeface="Roboto" pitchFamily="34" charset="-122"/>
                 <a:cs typeface="Roboto" pitchFamily="34" charset="-120"/>
               </a:rPr>
@@ -8885,7 +8885,7 @@
                 <a:solidFill>
                   <a:srgbClr val="2B2E3C"/>
                 </a:solidFill>
-                <a:latin typeface="Bitter" pitchFamily="34" charset="0"/>
+                <a:latin typeface="Calibri" pitchFamily="34" charset="0"/>
                 <a:ea typeface="Bitter" pitchFamily="34" charset="-122"/>
                 <a:cs typeface="Bitter" pitchFamily="34" charset="-120"/>
               </a:rPr>
@@ -8922,9 +8922,9 @@
             <a:r>
               <a:rPr lang="en-US" sz="625" dirty="0">
                 <a:solidFill>
-                  <a:srgbClr val="334155"/>
-                </a:solidFill>
-                <a:latin typeface="Roboto" pitchFamily="34" charset="0"/>
+                  <a:srgbClr val="2B2E3C"/>
+                </a:solidFill>
+                <a:latin typeface="Calibri" pitchFamily="34" charset="0"/>
                 <a:ea typeface="Roboto" pitchFamily="34" charset="-122"/>
                 <a:cs typeface="Roboto" pitchFamily="34" charset="-120"/>
               </a:rPr>
@@ -8949,7 +8949,7 @@
             <a:avLst/>
           </a:prstGeom>
           <a:solidFill>
-            <a:srgbClr val="F9FAFD"/>
+            <a:srgbClr val="FFFFFF"/>
           </a:solidFill>
           <a:ln w="12700">
             <a:solidFill>
@@ -8978,7 +8978,7 @@
             <a:avLst/>
           </a:prstGeom>
           <a:solidFill>
-            <a:srgbClr val="F9FAFD"/>
+            <a:srgbClr val="FFFFFF"/>
           </a:solidFill>
           <a:ln w="12700">
             <a:solidFill>
@@ -9007,7 +9007,7 @@
             <a:avLst/>
           </a:prstGeom>
           <a:solidFill>
-            <a:srgbClr val="F9FAFD"/>
+            <a:srgbClr val="FFFFFF"/>
           </a:solidFill>
           <a:ln w="12700">
             <a:solidFill>
@@ -9036,7 +9036,7 @@
             <a:avLst/>
           </a:prstGeom>
           <a:solidFill>
-            <a:srgbClr val="F9FAFD"/>
+            <a:srgbClr val="FFFFFF"/>
           </a:solidFill>
           <a:ln w="12700">
             <a:solidFill>
@@ -9065,7 +9065,7 @@
             <a:avLst/>
           </a:prstGeom>
           <a:solidFill>
-            <a:srgbClr val="F9FAFD"/>
+            <a:srgbClr val="FFFFFF"/>
           </a:solidFill>
           <a:ln w="12700">
             <a:solidFill>
@@ -9135,9 +9135,9 @@
             <a:r>
               <a:rPr lang="en-US" sz="750" b="1" dirty="0">
                 <a:solidFill>
-                  <a:srgbClr val="FFFFFF"/>
-                </a:solidFill>
-                <a:latin typeface="Bitter" pitchFamily="34" charset="0"/>
+                  <a:srgbClr val="2B2E3C"/>
+                </a:solidFill>
+                <a:latin typeface="Calibri" pitchFamily="34" charset="0"/>
                 <a:ea typeface="Bitter" pitchFamily="34" charset="-122"/>
                 <a:cs typeface="Bitter" pitchFamily="34" charset="-120"/>
               </a:rPr>
@@ -9176,7 +9176,7 @@
                 <a:solidFill>
                   <a:srgbClr val="2B2E3C"/>
                 </a:solidFill>
-                <a:latin typeface="Bitter" pitchFamily="34" charset="0"/>
+                <a:latin typeface="Calibri" pitchFamily="34" charset="0"/>
                 <a:ea typeface="Bitter" pitchFamily="34" charset="-122"/>
                 <a:cs typeface="Bitter" pitchFamily="34" charset="-120"/>
               </a:rPr>
@@ -9213,9 +9213,9 @@
             <a:r>
               <a:rPr lang="en-US" sz="625" dirty="0">
                 <a:solidFill>
-                  <a:srgbClr val="334155"/>
-                </a:solidFill>
-                <a:latin typeface="Roboto" pitchFamily="34" charset="0"/>
+                  <a:srgbClr val="2B2E3C"/>
+                </a:solidFill>
+                <a:latin typeface="Calibri" pitchFamily="34" charset="0"/>
                 <a:ea typeface="Roboto" pitchFamily="34" charset="-122"/>
                 <a:cs typeface="Roboto" pitchFamily="34" charset="-120"/>
               </a:rPr>
@@ -9254,7 +9254,7 @@
                 <a:solidFill>
                   <a:srgbClr val="2B2E3C"/>
                 </a:solidFill>
-                <a:latin typeface="Bitter" pitchFamily="34" charset="0"/>
+                <a:latin typeface="Calibri" pitchFamily="34" charset="0"/>
                 <a:ea typeface="Bitter" pitchFamily="34" charset="-122"/>
                 <a:cs typeface="Bitter" pitchFamily="34" charset="-120"/>
               </a:rPr>
@@ -9291,9 +9291,9 @@
             <a:r>
               <a:rPr lang="en-US" sz="625" dirty="0">
                 <a:solidFill>
-                  <a:srgbClr val="334155"/>
-                </a:solidFill>
-                <a:latin typeface="Roboto" pitchFamily="34" charset="0"/>
+                  <a:srgbClr val="2B2E3C"/>
+                </a:solidFill>
+                <a:latin typeface="Calibri" pitchFamily="34" charset="0"/>
                 <a:ea typeface="Roboto" pitchFamily="34" charset="-122"/>
                 <a:cs typeface="Roboto" pitchFamily="34" charset="-120"/>
               </a:rPr>
@@ -9504,9 +9504,9 @@
             <a:r>
               <a:rPr lang="en-US" sz="750" b="1" dirty="0">
                 <a:solidFill>
-                  <a:srgbClr val="FFFFFF"/>
-                </a:solidFill>
-                <a:latin typeface="Bitter" pitchFamily="34" charset="0"/>
+                  <a:srgbClr val="2B2E3C"/>
+                </a:solidFill>
+                <a:latin typeface="Calibri" pitchFamily="34" charset="0"/>
                 <a:ea typeface="Bitter" pitchFamily="34" charset="-122"/>
                 <a:cs typeface="Bitter" pitchFamily="34" charset="-120"/>
               </a:rPr>
@@ -9545,7 +9545,7 @@
                 <a:solidFill>
                   <a:srgbClr val="2B2E3C"/>
                 </a:solidFill>
-                <a:latin typeface="Bitter" pitchFamily="34" charset="0"/>
+                <a:latin typeface="Calibri" pitchFamily="34" charset="0"/>
                 <a:ea typeface="Bitter" pitchFamily="34" charset="-122"/>
                 <a:cs typeface="Bitter" pitchFamily="34" charset="-120"/>
               </a:rPr>
@@ -9582,9 +9582,9 @@
             <a:r>
               <a:rPr lang="en-US" sz="625" dirty="0">
                 <a:solidFill>
-                  <a:srgbClr val="334155"/>
-                </a:solidFill>
-                <a:latin typeface="Roboto" pitchFamily="34" charset="0"/>
+                  <a:srgbClr val="2B2E3C"/>
+                </a:solidFill>
+                <a:latin typeface="Calibri" pitchFamily="34" charset="0"/>
                 <a:ea typeface="Roboto" pitchFamily="34" charset="-122"/>
                 <a:cs typeface="Roboto" pitchFamily="34" charset="-120"/>
               </a:rPr>
@@ -9623,7 +9623,7 @@
                 <a:solidFill>
                   <a:srgbClr val="2B2E3C"/>
                 </a:solidFill>
-                <a:latin typeface="Bitter" pitchFamily="34" charset="0"/>
+                <a:latin typeface="Calibri" pitchFamily="34" charset="0"/>
                 <a:ea typeface="Bitter" pitchFamily="34" charset="-122"/>
                 <a:cs typeface="Bitter" pitchFamily="34" charset="-120"/>
               </a:rPr>
@@ -9660,9 +9660,9 @@
             <a:r>
               <a:rPr lang="en-US" sz="625" dirty="0">
                 <a:solidFill>
-                  <a:srgbClr val="334155"/>
-                </a:solidFill>
-                <a:latin typeface="Roboto" pitchFamily="34" charset="0"/>
+                  <a:srgbClr val="2B2E3C"/>
+                </a:solidFill>
+                <a:latin typeface="Calibri" pitchFamily="34" charset="0"/>
                 <a:ea typeface="Roboto" pitchFamily="34" charset="-122"/>
                 <a:cs typeface="Roboto" pitchFamily="34" charset="-120"/>
               </a:rPr>
@@ -9687,7 +9687,7 @@
             <a:avLst/>
           </a:prstGeom>
           <a:solidFill>
-            <a:srgbClr val="F9FAFD"/>
+            <a:srgbClr val="FFFFFF"/>
           </a:solidFill>
           <a:ln w="12700">
             <a:solidFill>
@@ -9716,7 +9716,7 @@
             <a:avLst/>
           </a:prstGeom>
           <a:solidFill>
-            <a:srgbClr val="F9FAFD"/>
+            <a:srgbClr val="FFFFFF"/>
           </a:solidFill>
           <a:ln w="12700">
             <a:solidFill>
@@ -9745,7 +9745,7 @@
             <a:avLst/>
           </a:prstGeom>
           <a:solidFill>
-            <a:srgbClr val="F9FAFD"/>
+            <a:srgbClr val="FFFFFF"/>
           </a:solidFill>
           <a:ln w="12700">
             <a:solidFill>
@@ -9774,7 +9774,7 @@
             <a:avLst/>
           </a:prstGeom>
           <a:solidFill>
-            <a:srgbClr val="F9FAFD"/>
+            <a:srgbClr val="FFFFFF"/>
           </a:solidFill>
           <a:ln w="12700">
             <a:solidFill>
@@ -9803,7 +9803,7 @@
             <a:avLst/>
           </a:prstGeom>
           <a:solidFill>
-            <a:srgbClr val="F9FAFD"/>
+            <a:srgbClr val="FFFFFF"/>
           </a:solidFill>
           <a:ln w="12700">
             <a:solidFill>
@@ -9873,9 +9873,9 @@
             <a:r>
               <a:rPr lang="en-US" sz="750" b="1" dirty="0">
                 <a:solidFill>
-                  <a:srgbClr val="FFFFFF"/>
-                </a:solidFill>
-                <a:latin typeface="Bitter" pitchFamily="34" charset="0"/>
+                  <a:srgbClr val="2B2E3C"/>
+                </a:solidFill>
+                <a:latin typeface="Calibri" pitchFamily="34" charset="0"/>
                 <a:ea typeface="Bitter" pitchFamily="34" charset="-122"/>
                 <a:cs typeface="Bitter" pitchFamily="34" charset="-120"/>
               </a:rPr>
@@ -9914,7 +9914,7 @@
                 <a:solidFill>
                   <a:srgbClr val="2B2E3C"/>
                 </a:solidFill>
-                <a:latin typeface="Bitter" pitchFamily="34" charset="0"/>
+                <a:latin typeface="Calibri" pitchFamily="34" charset="0"/>
                 <a:ea typeface="Bitter" pitchFamily="34" charset="-122"/>
                 <a:cs typeface="Bitter" pitchFamily="34" charset="-120"/>
               </a:rPr>
@@ -9951,9 +9951,9 @@
             <a:r>
               <a:rPr lang="en-US" sz="625" dirty="0">
                 <a:solidFill>
-                  <a:srgbClr val="334155"/>
-                </a:solidFill>
-                <a:latin typeface="Roboto" pitchFamily="34" charset="0"/>
+                  <a:srgbClr val="2B2E3C"/>
+                </a:solidFill>
+                <a:latin typeface="Calibri" pitchFamily="34" charset="0"/>
                 <a:ea typeface="Roboto" pitchFamily="34" charset="-122"/>
                 <a:cs typeface="Roboto" pitchFamily="34" charset="-120"/>
               </a:rPr>
@@ -9992,7 +9992,7 @@
                 <a:solidFill>
                   <a:srgbClr val="2B2E3C"/>
                 </a:solidFill>
-                <a:latin typeface="Bitter" pitchFamily="34" charset="0"/>
+                <a:latin typeface="Calibri" pitchFamily="34" charset="0"/>
                 <a:ea typeface="Bitter" pitchFamily="34" charset="-122"/>
                 <a:cs typeface="Bitter" pitchFamily="34" charset="-120"/>
               </a:rPr>
@@ -10029,9 +10029,9 @@
             <a:r>
               <a:rPr lang="en-US" sz="625" dirty="0">
                 <a:solidFill>
-                  <a:srgbClr val="334155"/>
-                </a:solidFill>
-                <a:latin typeface="Roboto" pitchFamily="34" charset="0"/>
+                  <a:srgbClr val="2B2E3C"/>
+                </a:solidFill>
+                <a:latin typeface="Calibri" pitchFamily="34" charset="0"/>
                 <a:ea typeface="Roboto" pitchFamily="34" charset="-122"/>
                 <a:cs typeface="Roboto" pitchFamily="34" charset="-120"/>
               </a:rPr>
@@ -10242,9 +10242,9 @@
             <a:r>
               <a:rPr lang="en-US" sz="750" b="1" dirty="0">
                 <a:solidFill>
-                  <a:srgbClr val="FFFFFF"/>
-                </a:solidFill>
-                <a:latin typeface="Bitter" pitchFamily="34" charset="0"/>
+                  <a:srgbClr val="2B2E3C"/>
+                </a:solidFill>
+                <a:latin typeface="Calibri" pitchFamily="34" charset="0"/>
                 <a:ea typeface="Bitter" pitchFamily="34" charset="-122"/>
                 <a:cs typeface="Bitter" pitchFamily="34" charset="-120"/>
               </a:rPr>
@@ -10283,7 +10283,7 @@
                 <a:solidFill>
                   <a:srgbClr val="2B2E3C"/>
                 </a:solidFill>
-                <a:latin typeface="Bitter" pitchFamily="34" charset="0"/>
+                <a:latin typeface="Calibri" pitchFamily="34" charset="0"/>
                 <a:ea typeface="Bitter" pitchFamily="34" charset="-122"/>
                 <a:cs typeface="Bitter" pitchFamily="34" charset="-120"/>
               </a:rPr>
@@ -10320,9 +10320,9 @@
             <a:r>
               <a:rPr lang="en-US" sz="625" dirty="0">
                 <a:solidFill>
-                  <a:srgbClr val="334155"/>
-                </a:solidFill>
-                <a:latin typeface="Roboto" pitchFamily="34" charset="0"/>
+                  <a:srgbClr val="2B2E3C"/>
+                </a:solidFill>
+                <a:latin typeface="Calibri" pitchFamily="34" charset="0"/>
                 <a:ea typeface="Roboto" pitchFamily="34" charset="-122"/>
                 <a:cs typeface="Roboto" pitchFamily="34" charset="-120"/>
               </a:rPr>
@@ -10361,7 +10361,7 @@
                 <a:solidFill>
                   <a:srgbClr val="2B2E3C"/>
                 </a:solidFill>
-                <a:latin typeface="Bitter" pitchFamily="34" charset="0"/>
+                <a:latin typeface="Calibri" pitchFamily="34" charset="0"/>
                 <a:ea typeface="Bitter" pitchFamily="34" charset="-122"/>
                 <a:cs typeface="Bitter" pitchFamily="34" charset="-120"/>
               </a:rPr>
@@ -10398,9 +10398,9 @@
             <a:r>
               <a:rPr lang="en-US" sz="625" dirty="0">
                 <a:solidFill>
-                  <a:srgbClr val="334155"/>
-                </a:solidFill>
-                <a:latin typeface="Roboto" pitchFamily="34" charset="0"/>
+                  <a:srgbClr val="2B2E3C"/>
+                </a:solidFill>
+                <a:latin typeface="Calibri" pitchFamily="34" charset="0"/>
                 <a:ea typeface="Roboto" pitchFamily="34" charset="-122"/>
                 <a:cs typeface="Roboto" pitchFamily="34" charset="-120"/>
               </a:rPr>
@@ -10425,7 +10425,7 @@
             <a:avLst/>
           </a:prstGeom>
           <a:solidFill>
-            <a:srgbClr val="FFF2CC"/>
+            <a:srgbClr val="FCE2CF"/>
           </a:solidFill>
           <a:ln w="12700">
             <a:solidFill>
@@ -10454,7 +10454,7 @@
             <a:avLst/>
           </a:prstGeom>
           <a:solidFill>
-            <a:srgbClr val="FFF2CC"/>
+            <a:srgbClr val="FCE2CF"/>
           </a:solidFill>
           <a:ln w="12700">
             <a:solidFill>
@@ -10483,7 +10483,7 @@
             <a:avLst/>
           </a:prstGeom>
           <a:solidFill>
-            <a:srgbClr val="FFF2CC"/>
+            <a:srgbClr val="FCE2CF"/>
           </a:solidFill>
           <a:ln w="12700">
             <a:solidFill>
@@ -10512,7 +10512,7 @@
             <a:avLst/>
           </a:prstGeom>
           <a:solidFill>
-            <a:srgbClr val="FFF2CC"/>
+            <a:srgbClr val="FCE2CF"/>
           </a:solidFill>
           <a:ln w="12700">
             <a:solidFill>
@@ -10541,7 +10541,7 @@
             <a:avLst/>
           </a:prstGeom>
           <a:solidFill>
-            <a:srgbClr val="FFF2CC"/>
+            <a:srgbClr val="FCE2CF"/>
           </a:solidFill>
           <a:ln w="12700">
             <a:solidFill>
@@ -10611,9 +10611,9 @@
             <a:r>
               <a:rPr lang="en-US" sz="750" b="1" dirty="0">
                 <a:solidFill>
-                  <a:srgbClr val="FFFFFF"/>
-                </a:solidFill>
-                <a:latin typeface="Bitter" pitchFamily="34" charset="0"/>
+                  <a:srgbClr val="2B2E3C"/>
+                </a:solidFill>
+                <a:latin typeface="Calibri" pitchFamily="34" charset="0"/>
                 <a:ea typeface="Bitter" pitchFamily="34" charset="-122"/>
                 <a:cs typeface="Bitter" pitchFamily="34" charset="-120"/>
               </a:rPr>
@@ -10652,7 +10652,7 @@
                 <a:solidFill>
                   <a:srgbClr val="2B2E3C"/>
                 </a:solidFill>
-                <a:latin typeface="Bitter" pitchFamily="34" charset="0"/>
+                <a:latin typeface="Calibri" pitchFamily="34" charset="0"/>
                 <a:ea typeface="Bitter" pitchFamily="34" charset="-122"/>
                 <a:cs typeface="Bitter" pitchFamily="34" charset="-120"/>
               </a:rPr>
@@ -10689,9 +10689,9 @@
             <a:r>
               <a:rPr lang="en-US" sz="625" dirty="0">
                 <a:solidFill>
-                  <a:srgbClr val="334155"/>
-                </a:solidFill>
-                <a:latin typeface="Roboto" pitchFamily="34" charset="0"/>
+                  <a:srgbClr val="2B2E3C"/>
+                </a:solidFill>
+                <a:latin typeface="Calibri" pitchFamily="34" charset="0"/>
                 <a:ea typeface="Roboto" pitchFamily="34" charset="-122"/>
                 <a:cs typeface="Roboto" pitchFamily="34" charset="-120"/>
               </a:rPr>
@@ -10730,7 +10730,7 @@
                 <a:solidFill>
                   <a:srgbClr val="2B2E3C"/>
                 </a:solidFill>
-                <a:latin typeface="Bitter" pitchFamily="34" charset="0"/>
+                <a:latin typeface="Calibri" pitchFamily="34" charset="0"/>
                 <a:ea typeface="Bitter" pitchFamily="34" charset="-122"/>
                 <a:cs typeface="Bitter" pitchFamily="34" charset="-120"/>
               </a:rPr>
@@ -10767,9 +10767,9 @@
             <a:r>
               <a:rPr lang="en-US" sz="625" dirty="0">
                 <a:solidFill>
-                  <a:srgbClr val="334155"/>
-                </a:solidFill>
-                <a:latin typeface="Roboto" pitchFamily="34" charset="0"/>
+                  <a:srgbClr val="2B2E3C"/>
+                </a:solidFill>
+                <a:latin typeface="Calibri" pitchFamily="34" charset="0"/>
                 <a:ea typeface="Roboto" pitchFamily="34" charset="-122"/>
                 <a:cs typeface="Roboto" pitchFamily="34" charset="-120"/>
               </a:rPr>
@@ -10806,9 +10806,9 @@
             <a:r>
               <a:rPr lang="en-US" sz="531" i="1" dirty="0">
                 <a:solidFill>
-                  <a:srgbClr val="64748B"/>
-                </a:solidFill>
-                <a:latin typeface="Open Sans" pitchFamily="34" charset="0"/>
+                  <a:srgbClr val="2B2E3C"/>
+                </a:solidFill>
+                <a:latin typeface="Calibri" pitchFamily="34" charset="0"/>
                 <a:ea typeface="Open Sans" pitchFamily="34" charset="-122"/>
                 <a:cs typeface="Open Sans" pitchFamily="34" charset="-120"/>
               </a:rPr>
@@ -10865,7 +10865,7 @@
             <a:avLst/>
           </a:prstGeom>
           <a:solidFill>
-            <a:srgbClr val="2C3F42"/>
+            <a:srgbClr val="FFF8F0"/>
           </a:solidFill>
           <a:ln w="12700">
             <a:solidFill>
@@ -10906,9 +10906,9 @@
             <a:r>
               <a:rPr lang="en-US" sz="531" b="1" spc="300" kern="0" dirty="0">
                 <a:solidFill>
-                  <a:srgbClr val="E2C8B5"/>
-                </a:solidFill>
-                <a:latin typeface="Open Sans" pitchFamily="34" charset="0"/>
+                  <a:srgbClr val="AF2C20"/>
+                </a:solidFill>
+                <a:latin typeface="Calibri" pitchFamily="34" charset="0"/>
                 <a:ea typeface="Open Sans" pitchFamily="34" charset="-122"/>
                 <a:cs typeface="Open Sans" pitchFamily="34" charset="-120"/>
               </a:rPr>
@@ -10945,9 +10945,9 @@
             <a:r>
               <a:rPr lang="en-US" sz="1500" b="1" dirty="0">
                 <a:solidFill>
-                  <a:srgbClr val="FFFFFF"/>
-                </a:solidFill>
-                <a:latin typeface="Bitter" pitchFamily="34" charset="0"/>
+                  <a:srgbClr val="2B2E3C"/>
+                </a:solidFill>
+                <a:latin typeface="Calibri" pitchFamily="34" charset="0"/>
                 <a:ea typeface="Bitter" pitchFamily="34" charset="-122"/>
                 <a:cs typeface="Bitter" pitchFamily="34" charset="-120"/>
               </a:rPr>
@@ -10972,7 +10972,7 @@
             <a:avLst/>
           </a:prstGeom>
           <a:solidFill>
-            <a:srgbClr val="2C3F42"/>
+            <a:srgbClr val="FFF8F0"/>
           </a:solidFill>
           <a:ln w="12700">
             <a:solidFill>
@@ -11013,9 +11013,9 @@
             <a:r>
               <a:rPr lang="en-US" sz="562" b="1" dirty="0">
                 <a:solidFill>
-                  <a:srgbClr val="E2C8B5"/>
-                </a:solidFill>
-                <a:latin typeface="Bitter" pitchFamily="34" charset="0"/>
+                  <a:srgbClr val="AF2C20"/>
+                </a:solidFill>
+                <a:latin typeface="Calibri" pitchFamily="34" charset="0"/>
                 <a:ea typeface="Bitter" pitchFamily="34" charset="-122"/>
                 <a:cs typeface="Bitter" pitchFamily="34" charset="-120"/>
               </a:rPr>
@@ -11040,7 +11040,7 @@
             <a:avLst/>
           </a:prstGeom>
           <a:solidFill>
-            <a:srgbClr val="2C3F42"/>
+            <a:srgbClr val="FFF8F0"/>
           </a:solidFill>
           <a:ln w="12700">
             <a:solidFill>
@@ -11081,9 +11081,9 @@
             <a:r>
               <a:rPr lang="en-US" sz="562" b="1" dirty="0">
                 <a:solidFill>
-                  <a:srgbClr val="E2C8B5"/>
-                </a:solidFill>
-                <a:latin typeface="Bitter" pitchFamily="34" charset="0"/>
+                  <a:srgbClr val="AF2C20"/>
+                </a:solidFill>
+                <a:latin typeface="Calibri" pitchFamily="34" charset="0"/>
                 <a:ea typeface="Bitter" pitchFamily="34" charset="-122"/>
                 <a:cs typeface="Bitter" pitchFamily="34" charset="-120"/>
               </a:rPr>
@@ -11108,7 +11108,7 @@
             <a:avLst/>
           </a:prstGeom>
           <a:solidFill>
-            <a:srgbClr val="2C3F42"/>
+            <a:srgbClr val="FFF8F0"/>
           </a:solidFill>
           <a:ln w="12700">
             <a:solidFill>
@@ -11149,9 +11149,9 @@
             <a:r>
               <a:rPr lang="en-US" sz="468" dirty="0">
                 <a:solidFill>
-                  <a:srgbClr val="E2C8B5"/>
-                </a:solidFill>
-                <a:latin typeface="Open Sans" pitchFamily="34" charset="0"/>
+                  <a:srgbClr val="AF2C20"/>
+                </a:solidFill>
+                <a:latin typeface="Calibri" pitchFamily="34" charset="0"/>
                 <a:ea typeface="Open Sans" pitchFamily="34" charset="-122"/>
                 <a:cs typeface="Open Sans" pitchFamily="34" charset="-120"/>
               </a:rPr>
@@ -11176,7 +11176,7 @@
             <a:avLst/>
           </a:prstGeom>
           <a:solidFill>
-            <a:srgbClr val="2C3F42"/>
+            <a:srgbClr val="FFF8F0"/>
           </a:solidFill>
           <a:ln w="12700">
             <a:solidFill>
@@ -11217,9 +11217,9 @@
             <a:r>
               <a:rPr lang="en-US" sz="468" dirty="0">
                 <a:solidFill>
-                  <a:srgbClr val="E2C8B5"/>
-                </a:solidFill>
-                <a:latin typeface="Open Sans" pitchFamily="34" charset="0"/>
+                  <a:srgbClr val="AF2C20"/>
+                </a:solidFill>
+                <a:latin typeface="Calibri" pitchFamily="34" charset="0"/>
                 <a:ea typeface="Open Sans" pitchFamily="34" charset="-122"/>
                 <a:cs typeface="Open Sans" pitchFamily="34" charset="-120"/>
               </a:rPr>
@@ -11244,7 +11244,7 @@
             <a:avLst/>
           </a:prstGeom>
           <a:solidFill>
-            <a:srgbClr val="2C3F42"/>
+            <a:srgbClr val="FFF8F0"/>
           </a:solidFill>
           <a:ln w="12700">
             <a:solidFill>
@@ -11285,9 +11285,9 @@
             <a:r>
               <a:rPr lang="en-US" sz="468" dirty="0">
                 <a:solidFill>
-                  <a:srgbClr val="E2C8B5"/>
-                </a:solidFill>
-                <a:latin typeface="Open Sans" pitchFamily="34" charset="0"/>
+                  <a:srgbClr val="AF2C20"/>
+                </a:solidFill>
+                <a:latin typeface="Calibri" pitchFamily="34" charset="0"/>
                 <a:ea typeface="Open Sans" pitchFamily="34" charset="-122"/>
                 <a:cs typeface="Open Sans" pitchFamily="34" charset="-120"/>
               </a:rPr>
@@ -11312,7 +11312,7 @@
             <a:avLst/>
           </a:prstGeom>
           <a:solidFill>
-            <a:srgbClr val="2C3F42"/>
+            <a:srgbClr val="FFF8F0"/>
           </a:solidFill>
           <a:ln w="12700">
             <a:solidFill>
@@ -11353,9 +11353,9 @@
             <a:r>
               <a:rPr lang="en-US" sz="468" dirty="0">
                 <a:solidFill>
-                  <a:srgbClr val="E2C8B5"/>
-                </a:solidFill>
-                <a:latin typeface="Open Sans" pitchFamily="34" charset="0"/>
+                  <a:srgbClr val="AF2C20"/>
+                </a:solidFill>
+                <a:latin typeface="Calibri" pitchFamily="34" charset="0"/>
                 <a:ea typeface="Open Sans" pitchFamily="34" charset="-122"/>
                 <a:cs typeface="Open Sans" pitchFamily="34" charset="-120"/>
               </a:rPr>
@@ -11380,7 +11380,7 @@
             <a:avLst/>
           </a:prstGeom>
           <a:solidFill>
-            <a:srgbClr val="2C3F42"/>
+            <a:srgbClr val="FFF8F0"/>
           </a:solidFill>
           <a:ln w="12700">
             <a:solidFill>
@@ -11421,9 +11421,9 @@
             <a:r>
               <a:rPr lang="en-US" sz="468" dirty="0">
                 <a:solidFill>
-                  <a:srgbClr val="E2C8B5"/>
-                </a:solidFill>
-                <a:latin typeface="Open Sans" pitchFamily="34" charset="0"/>
+                  <a:srgbClr val="AF2C20"/>
+                </a:solidFill>
+                <a:latin typeface="Calibri" pitchFamily="34" charset="0"/>
                 <a:ea typeface="Open Sans" pitchFamily="34" charset="-122"/>
                 <a:cs typeface="Open Sans" pitchFamily="34" charset="-120"/>
               </a:rPr>
@@ -11448,7 +11448,7 @@
             <a:avLst/>
           </a:prstGeom>
           <a:solidFill>
-            <a:srgbClr val="2C3F42"/>
+            <a:srgbClr val="FFF8F0"/>
           </a:solidFill>
           <a:ln w="12700">
             <a:solidFill>
@@ -11489,9 +11489,9 @@
             <a:r>
               <a:rPr lang="en-US" sz="468" dirty="0">
                 <a:solidFill>
-                  <a:srgbClr val="E2C8B5"/>
-                </a:solidFill>
-                <a:latin typeface="Open Sans" pitchFamily="34" charset="0"/>
+                  <a:srgbClr val="AF2C20"/>
+                </a:solidFill>
+                <a:latin typeface="Calibri" pitchFamily="34" charset="0"/>
                 <a:ea typeface="Open Sans" pitchFamily="34" charset="-122"/>
                 <a:cs typeface="Open Sans" pitchFamily="34" charset="-120"/>
               </a:rPr>
@@ -11516,7 +11516,7 @@
             <a:avLst/>
           </a:prstGeom>
           <a:solidFill>
-            <a:srgbClr val="2C3F42"/>
+            <a:srgbClr val="FFF8F0"/>
           </a:solidFill>
           <a:ln w="12700">
             <a:solidFill>
@@ -11557,9 +11557,9 @@
             <a:r>
               <a:rPr lang="en-US" sz="468" dirty="0">
                 <a:solidFill>
-                  <a:srgbClr val="E2C8B5"/>
-                </a:solidFill>
-                <a:latin typeface="Open Sans" pitchFamily="34" charset="0"/>
+                  <a:srgbClr val="AF2C20"/>
+                </a:solidFill>
+                <a:latin typeface="Calibri" pitchFamily="34" charset="0"/>
                 <a:ea typeface="Open Sans" pitchFamily="34" charset="-122"/>
                 <a:cs typeface="Open Sans" pitchFamily="34" charset="-120"/>
               </a:rPr>
@@ -11584,7 +11584,7 @@
             <a:avLst/>
           </a:prstGeom>
           <a:solidFill>
-            <a:srgbClr val="2C3F42"/>
+            <a:srgbClr val="FFF8F0"/>
           </a:solidFill>
           <a:ln w="12700">
             <a:solidFill>
@@ -11625,9 +11625,9 @@
             <a:r>
               <a:rPr lang="en-US" sz="468" dirty="0">
                 <a:solidFill>
-                  <a:srgbClr val="E2C8B5"/>
-                </a:solidFill>
-                <a:latin typeface="Open Sans" pitchFamily="34" charset="0"/>
+                  <a:srgbClr val="AF2C20"/>
+                </a:solidFill>
+                <a:latin typeface="Calibri" pitchFamily="34" charset="0"/>
                 <a:ea typeface="Open Sans" pitchFamily="34" charset="-122"/>
                 <a:cs typeface="Open Sans" pitchFamily="34" charset="-120"/>
               </a:rPr>
@@ -11652,7 +11652,7 @@
             <a:avLst/>
           </a:prstGeom>
           <a:solidFill>
-            <a:srgbClr val="2C3F42"/>
+            <a:srgbClr val="FFF8F0"/>
           </a:solidFill>
           <a:ln w="12700">
             <a:solidFill>
@@ -11693,9 +11693,9 @@
             <a:r>
               <a:rPr lang="en-US" sz="468" dirty="0">
                 <a:solidFill>
-                  <a:srgbClr val="E2C8B5"/>
-                </a:solidFill>
-                <a:latin typeface="Open Sans" pitchFamily="34" charset="0"/>
+                  <a:srgbClr val="AF2C20"/>
+                </a:solidFill>
+                <a:latin typeface="Calibri" pitchFamily="34" charset="0"/>
                 <a:ea typeface="Open Sans" pitchFamily="34" charset="-122"/>
                 <a:cs typeface="Open Sans" pitchFamily="34" charset="-120"/>
               </a:rPr>
@@ -11720,7 +11720,7 @@
             <a:avLst/>
           </a:prstGeom>
           <a:solidFill>
-            <a:srgbClr val="2C3F42"/>
+            <a:srgbClr val="FFF8F0"/>
           </a:solidFill>
           <a:ln w="12700">
             <a:solidFill>
@@ -11761,9 +11761,9 @@
             <a:r>
               <a:rPr lang="en-US" sz="468" dirty="0">
                 <a:solidFill>
-                  <a:srgbClr val="E2C8B5"/>
-                </a:solidFill>
-                <a:latin typeface="Open Sans" pitchFamily="34" charset="0"/>
+                  <a:srgbClr val="AF2C20"/>
+                </a:solidFill>
+                <a:latin typeface="Calibri" pitchFamily="34" charset="0"/>
                 <a:ea typeface="Open Sans" pitchFamily="34" charset="-122"/>
                 <a:cs typeface="Open Sans" pitchFamily="34" charset="-120"/>
               </a:rPr>
@@ -11788,7 +11788,7 @@
             <a:avLst/>
           </a:prstGeom>
           <a:solidFill>
-            <a:srgbClr val="2C3F42"/>
+            <a:srgbClr val="FFF8F0"/>
           </a:solidFill>
           <a:ln w="12700">
             <a:solidFill>
@@ -11829,9 +11829,9 @@
             <a:r>
               <a:rPr lang="en-US" sz="468" dirty="0">
                 <a:solidFill>
-                  <a:srgbClr val="E2C8B5"/>
-                </a:solidFill>
-                <a:latin typeface="Open Sans" pitchFamily="34" charset="0"/>
+                  <a:srgbClr val="AF2C20"/>
+                </a:solidFill>
+                <a:latin typeface="Calibri" pitchFamily="34" charset="0"/>
                 <a:ea typeface="Open Sans" pitchFamily="34" charset="-122"/>
                 <a:cs typeface="Open Sans" pitchFamily="34" charset="-120"/>
               </a:rPr>
@@ -11856,7 +11856,7 @@
             <a:avLst/>
           </a:prstGeom>
           <a:solidFill>
-            <a:srgbClr val="2C3F42"/>
+            <a:srgbClr val="FFF8F0"/>
           </a:solidFill>
           <a:ln w="12700">
             <a:solidFill>
@@ -11897,9 +11897,9 @@
             <a:r>
               <a:rPr lang="en-US" sz="468" dirty="0">
                 <a:solidFill>
-                  <a:srgbClr val="E2C8B5"/>
-                </a:solidFill>
-                <a:latin typeface="Open Sans" pitchFamily="34" charset="0"/>
+                  <a:srgbClr val="AF2C20"/>
+                </a:solidFill>
+                <a:latin typeface="Calibri" pitchFamily="34" charset="0"/>
                 <a:ea typeface="Open Sans" pitchFamily="34" charset="-122"/>
                 <a:cs typeface="Open Sans" pitchFamily="34" charset="-120"/>
               </a:rPr>
@@ -11924,7 +11924,7 @@
             <a:avLst/>
           </a:prstGeom>
           <a:solidFill>
-            <a:srgbClr val="1A2D30"/>
+            <a:srgbClr val="FFF8F0"/>
           </a:solidFill>
           <a:ln w="12700">
             <a:solidFill>
@@ -11965,9 +11965,9 @@
             <a:r>
               <a:rPr lang="en-US" sz="468" dirty="0">
                 <a:solidFill>
-                  <a:srgbClr val="E2C8B5"/>
-                </a:solidFill>
-                <a:latin typeface="Open Sans" pitchFamily="34" charset="0"/>
+                  <a:srgbClr val="AF2C20"/>
+                </a:solidFill>
+                <a:latin typeface="Calibri" pitchFamily="34" charset="0"/>
                 <a:ea typeface="Open Sans" pitchFamily="34" charset="-122"/>
                 <a:cs typeface="Open Sans" pitchFamily="34" charset="-120"/>
               </a:rPr>
@@ -11992,7 +11992,7 @@
             <a:avLst/>
           </a:prstGeom>
           <a:solidFill>
-            <a:srgbClr val="1A2D30"/>
+            <a:srgbClr val="FFF8F0"/>
           </a:solidFill>
           <a:ln w="12700">
             <a:solidFill>
@@ -12033,9 +12033,9 @@
             <a:r>
               <a:rPr lang="en-US" sz="468" dirty="0">
                 <a:solidFill>
-                  <a:srgbClr val="E2C8B5"/>
-                </a:solidFill>
-                <a:latin typeface="Open Sans" pitchFamily="34" charset="0"/>
+                  <a:srgbClr val="AF2C20"/>
+                </a:solidFill>
+                <a:latin typeface="Calibri" pitchFamily="34" charset="0"/>
                 <a:ea typeface="Open Sans" pitchFamily="34" charset="-122"/>
                 <a:cs typeface="Open Sans" pitchFamily="34" charset="-120"/>
               </a:rPr>
@@ -12060,7 +12060,7 @@
             <a:avLst/>
           </a:prstGeom>
           <a:solidFill>
-            <a:srgbClr val="1A2D30"/>
+            <a:srgbClr val="FFF8F0"/>
           </a:solidFill>
           <a:ln w="12700">
             <a:solidFill>
@@ -12101,9 +12101,9 @@
             <a:r>
               <a:rPr lang="en-US" sz="468" dirty="0">
                 <a:solidFill>
-                  <a:srgbClr val="E2C8B5"/>
-                </a:solidFill>
-                <a:latin typeface="Open Sans" pitchFamily="34" charset="0"/>
+                  <a:srgbClr val="AF2C20"/>
+                </a:solidFill>
+                <a:latin typeface="Calibri" pitchFamily="34" charset="0"/>
                 <a:ea typeface="Open Sans" pitchFamily="34" charset="-122"/>
                 <a:cs typeface="Open Sans" pitchFamily="34" charset="-120"/>
               </a:rPr>
@@ -12128,7 +12128,7 @@
             <a:avLst/>
           </a:prstGeom>
           <a:solidFill>
-            <a:srgbClr val="1A2D30"/>
+            <a:srgbClr val="FFF8F0"/>
           </a:solidFill>
           <a:ln w="12700">
             <a:solidFill>
@@ -12169,9 +12169,9 @@
             <a:r>
               <a:rPr lang="en-US" sz="468" dirty="0">
                 <a:solidFill>
-                  <a:srgbClr val="E2C8B5"/>
-                </a:solidFill>
-                <a:latin typeface="Open Sans" pitchFamily="34" charset="0"/>
+                  <a:srgbClr val="AF2C20"/>
+                </a:solidFill>
+                <a:latin typeface="Calibri" pitchFamily="34" charset="0"/>
                 <a:ea typeface="Open Sans" pitchFamily="34" charset="-122"/>
                 <a:cs typeface="Open Sans" pitchFamily="34" charset="-120"/>
               </a:rPr>
@@ -12196,7 +12196,7 @@
             <a:avLst/>
           </a:prstGeom>
           <a:solidFill>
-            <a:srgbClr val="1A2D30"/>
+            <a:srgbClr val="FFF8F0"/>
           </a:solidFill>
           <a:ln w="12700">
             <a:solidFill>
@@ -12237,9 +12237,9 @@
             <a:r>
               <a:rPr lang="en-US" sz="468" dirty="0">
                 <a:solidFill>
-                  <a:srgbClr val="E2C8B5"/>
-                </a:solidFill>
-                <a:latin typeface="Open Sans" pitchFamily="34" charset="0"/>
+                  <a:srgbClr val="AF2C20"/>
+                </a:solidFill>
+                <a:latin typeface="Calibri" pitchFamily="34" charset="0"/>
                 <a:ea typeface="Open Sans" pitchFamily="34" charset="-122"/>
                 <a:cs typeface="Open Sans" pitchFamily="34" charset="-120"/>
               </a:rPr>
@@ -12264,7 +12264,7 @@
             <a:avLst/>
           </a:prstGeom>
           <a:solidFill>
-            <a:srgbClr val="1A2D30"/>
+            <a:srgbClr val="FFF8F0"/>
           </a:solidFill>
           <a:ln w="12700">
             <a:solidFill>
@@ -12305,9 +12305,9 @@
             <a:r>
               <a:rPr lang="en-US" sz="468" dirty="0">
                 <a:solidFill>
-                  <a:srgbClr val="E2C8B5"/>
-                </a:solidFill>
-                <a:latin typeface="Open Sans" pitchFamily="34" charset="0"/>
+                  <a:srgbClr val="AF2C20"/>
+                </a:solidFill>
+                <a:latin typeface="Calibri" pitchFamily="34" charset="0"/>
                 <a:ea typeface="Open Sans" pitchFamily="34" charset="-122"/>
                 <a:cs typeface="Open Sans" pitchFamily="34" charset="-120"/>
               </a:rPr>
@@ -12332,7 +12332,7 @@
             <a:avLst/>
           </a:prstGeom>
           <a:solidFill>
-            <a:srgbClr val="2C3F42"/>
+            <a:srgbClr val="FFF8F0"/>
           </a:solidFill>
           <a:ln w="12700">
             <a:solidFill>
@@ -12373,9 +12373,9 @@
             <a:r>
               <a:rPr lang="en-US" sz="625" b="1" dirty="0">
                 <a:solidFill>
-                  <a:srgbClr val="FFFFFF"/>
-                </a:solidFill>
-                <a:latin typeface="Bitter" pitchFamily="34" charset="0"/>
+                  <a:srgbClr val="2B2E3C"/>
+                </a:solidFill>
+                <a:latin typeface="Calibri" pitchFamily="34" charset="0"/>
                 <a:ea typeface="Bitter" pitchFamily="34" charset="-122"/>
                 <a:cs typeface="Bitter" pitchFamily="34" charset="-120"/>
               </a:rPr>
@@ -12400,7 +12400,7 @@
             <a:avLst/>
           </a:prstGeom>
           <a:solidFill>
-            <a:srgbClr val="2C3F42"/>
+            <a:srgbClr val="FFF8F0"/>
           </a:solidFill>
           <a:ln w="12700">
             <a:solidFill>
@@ -12441,9 +12441,9 @@
             <a:r>
               <a:rPr lang="en-US" sz="562" b="1" spc="100" kern="0" dirty="0">
                 <a:solidFill>
-                  <a:srgbClr val="E2C8B5"/>
-                </a:solidFill>
-                <a:latin typeface="Bitter" pitchFamily="34" charset="0"/>
+                  <a:srgbClr val="AF2C20"/>
+                </a:solidFill>
+                <a:latin typeface="Calibri" pitchFamily="34" charset="0"/>
                 <a:ea typeface="Bitter" pitchFamily="34" charset="-122"/>
                 <a:cs typeface="Bitter" pitchFamily="34" charset="-120"/>
               </a:rPr>
@@ -12468,7 +12468,7 @@
             <a:avLst/>
           </a:prstGeom>
           <a:solidFill>
-            <a:srgbClr val="3D6B6F"/>
+            <a:srgbClr val="E2C8B5"/>
           </a:solidFill>
           <a:ln w="12700">
             <a:solidFill>
@@ -12509,9 +12509,9 @@
             <a:r>
               <a:rPr lang="en-US" sz="468" b="1" dirty="0">
                 <a:solidFill>
-                  <a:srgbClr val="FFFFFF"/>
-                </a:solidFill>
-                <a:latin typeface="Open Sans" pitchFamily="34" charset="0"/>
+                  <a:srgbClr val="2B2E3C"/>
+                </a:solidFill>
+                <a:latin typeface="Calibri" pitchFamily="34" charset="0"/>
                 <a:ea typeface="Open Sans" pitchFamily="34" charset="-122"/>
                 <a:cs typeface="Open Sans" pitchFamily="34" charset="-120"/>
               </a:rPr>
@@ -12577,9 +12577,9 @@
             <a:r>
               <a:rPr lang="en-US" sz="468" b="1" dirty="0">
                 <a:solidFill>
-                  <a:srgbClr val="FFFFFF"/>
-                </a:solidFill>
-                <a:latin typeface="Open Sans" pitchFamily="34" charset="0"/>
+                  <a:srgbClr val="2B2E3C"/>
+                </a:solidFill>
+                <a:latin typeface="Calibri" pitchFamily="34" charset="0"/>
                 <a:ea typeface="Open Sans" pitchFamily="34" charset="-122"/>
                 <a:cs typeface="Open Sans" pitchFamily="34" charset="-120"/>
               </a:rPr>
@@ -12645,9 +12645,9 @@
             <a:r>
               <a:rPr lang="en-US" sz="468" b="1" dirty="0">
                 <a:solidFill>
-                  <a:srgbClr val="FFFFFF"/>
-                </a:solidFill>
-                <a:latin typeface="Open Sans" pitchFamily="34" charset="0"/>
+                  <a:srgbClr val="2B2E3C"/>
+                </a:solidFill>
+                <a:latin typeface="Calibri" pitchFamily="34" charset="0"/>
                 <a:ea typeface="Open Sans" pitchFamily="34" charset="-122"/>
                 <a:cs typeface="Open Sans" pitchFamily="34" charset="-120"/>
               </a:rPr>
@@ -12672,7 +12672,7 @@
             <a:avLst/>
           </a:prstGeom>
           <a:solidFill>
-            <a:srgbClr val="7F1F17"/>
+            <a:srgbClr val="AF2C20"/>
           </a:solidFill>
           <a:ln w="12700">
             <a:solidFill>
@@ -12713,9 +12713,9 @@
             <a:r>
               <a:rPr lang="en-US" sz="468" b="1" dirty="0">
                 <a:solidFill>
-                  <a:srgbClr val="FFFFFF"/>
-                </a:solidFill>
-                <a:latin typeface="Open Sans" pitchFamily="34" charset="0"/>
+                  <a:srgbClr val="2B2E3C"/>
+                </a:solidFill>
+                <a:latin typeface="Calibri" pitchFamily="34" charset="0"/>
                 <a:ea typeface="Open Sans" pitchFamily="34" charset="-122"/>
                 <a:cs typeface="Open Sans" pitchFamily="34" charset="-120"/>
               </a:rPr>
@@ -12740,7 +12740,7 @@
             <a:avLst/>
           </a:prstGeom>
           <a:solidFill>
-            <a:srgbClr val="2C3F42"/>
+            <a:srgbClr val="FFF8F0"/>
           </a:solidFill>
           <a:ln w="12700">
             <a:solidFill>
@@ -12781,9 +12781,9 @@
             <a:r>
               <a:rPr lang="en-US" sz="562" b="1" spc="100" kern="0" dirty="0">
                 <a:solidFill>
-                  <a:srgbClr val="E2C8B5"/>
-                </a:solidFill>
-                <a:latin typeface="Bitter" pitchFamily="34" charset="0"/>
+                  <a:srgbClr val="AF2C20"/>
+                </a:solidFill>
+                <a:latin typeface="Calibri" pitchFamily="34" charset="0"/>
                 <a:ea typeface="Bitter" pitchFamily="34" charset="-122"/>
                 <a:cs typeface="Bitter" pitchFamily="34" charset="-120"/>
               </a:rPr>
@@ -12851,7 +12851,7 @@
                 <a:solidFill>
                   <a:srgbClr val="2B2E3C"/>
                 </a:solidFill>
-                <a:latin typeface="Roboto" pitchFamily="34" charset="0"/>
+                <a:latin typeface="Calibri" pitchFamily="34" charset="0"/>
                 <a:ea typeface="Roboto" pitchFamily="34" charset="-122"/>
                 <a:cs typeface="Roboto" pitchFamily="34" charset="-120"/>
               </a:rPr>
@@ -12917,9 +12917,9 @@
             <a:r>
               <a:rPr lang="en-US" sz="468" b="1" dirty="0">
                 <a:solidFill>
-                  <a:srgbClr val="FFFFFF"/>
-                </a:solidFill>
-                <a:latin typeface="Open Sans" pitchFamily="34" charset="0"/>
+                  <a:srgbClr val="2B2E3C"/>
+                </a:solidFill>
+                <a:latin typeface="Calibri" pitchFamily="34" charset="0"/>
                 <a:ea typeface="Open Sans" pitchFamily="34" charset="-122"/>
                 <a:cs typeface="Open Sans" pitchFamily="34" charset="-120"/>
               </a:rPr>
@@ -12985,9 +12985,9 @@
             <a:r>
               <a:rPr lang="en-US" sz="468" b="1" dirty="0">
                 <a:solidFill>
-                  <a:srgbClr val="FFFFFF"/>
-                </a:solidFill>
-                <a:latin typeface="Open Sans" pitchFamily="34" charset="0"/>
+                  <a:srgbClr val="2B2E3C"/>
+                </a:solidFill>
+                <a:latin typeface="Calibri" pitchFamily="34" charset="0"/>
                 <a:ea typeface="Open Sans" pitchFamily="34" charset="-122"/>
                 <a:cs typeface="Open Sans" pitchFamily="34" charset="-120"/>
               </a:rPr>
@@ -13055,7 +13055,7 @@
                 <a:solidFill>
                   <a:srgbClr val="2B2E3C"/>
                 </a:solidFill>
-                <a:latin typeface="Roboto" pitchFamily="34" charset="0"/>
+                <a:latin typeface="Calibri" pitchFamily="34" charset="0"/>
                 <a:ea typeface="Roboto" pitchFamily="34" charset="-122"/>
                 <a:cs typeface="Roboto" pitchFamily="34" charset="-120"/>
               </a:rPr>
@@ -13121,9 +13121,9 @@
             <a:r>
               <a:rPr lang="en-US" sz="468" b="1" dirty="0">
                 <a:solidFill>
-                  <a:srgbClr val="FFFFFF"/>
-                </a:solidFill>
-                <a:latin typeface="Open Sans" pitchFamily="34" charset="0"/>
+                  <a:srgbClr val="2B2E3C"/>
+                </a:solidFill>
+                <a:latin typeface="Calibri" pitchFamily="34" charset="0"/>
                 <a:ea typeface="Open Sans" pitchFamily="34" charset="-122"/>
                 <a:cs typeface="Open Sans" pitchFamily="34" charset="-120"/>
               </a:rPr>
@@ -13189,9 +13189,9 @@
             <a:r>
               <a:rPr lang="en-US" sz="468" b="1" dirty="0">
                 <a:solidFill>
-                  <a:srgbClr val="FFFFFF"/>
-                </a:solidFill>
-                <a:latin typeface="Open Sans" pitchFamily="34" charset="0"/>
+                  <a:srgbClr val="2B2E3C"/>
+                </a:solidFill>
+                <a:latin typeface="Calibri" pitchFamily="34" charset="0"/>
                 <a:ea typeface="Open Sans" pitchFamily="34" charset="-122"/>
                 <a:cs typeface="Open Sans" pitchFamily="34" charset="-120"/>
               </a:rPr>
@@ -13259,7 +13259,7 @@
                 <a:solidFill>
                   <a:srgbClr val="2B2E3C"/>
                 </a:solidFill>
-                <a:latin typeface="Roboto" pitchFamily="34" charset="0"/>
+                <a:latin typeface="Calibri" pitchFamily="34" charset="0"/>
                 <a:ea typeface="Roboto" pitchFamily="34" charset="-122"/>
                 <a:cs typeface="Roboto" pitchFamily="34" charset="-120"/>
               </a:rPr>
@@ -13325,9 +13325,9 @@
             <a:r>
               <a:rPr lang="en-US" sz="468" b="1" dirty="0">
                 <a:solidFill>
-                  <a:srgbClr val="FFFFFF"/>
-                </a:solidFill>
-                <a:latin typeface="Open Sans" pitchFamily="34" charset="0"/>
+                  <a:srgbClr val="2B2E3C"/>
+                </a:solidFill>
+                <a:latin typeface="Calibri" pitchFamily="34" charset="0"/>
                 <a:ea typeface="Open Sans" pitchFamily="34" charset="-122"/>
                 <a:cs typeface="Open Sans" pitchFamily="34" charset="-120"/>
               </a:rPr>
@@ -13393,9 +13393,9 @@
             <a:r>
               <a:rPr lang="en-US" sz="468" b="1" dirty="0">
                 <a:solidFill>
-                  <a:srgbClr val="FFFFFF"/>
-                </a:solidFill>
-                <a:latin typeface="Open Sans" pitchFamily="34" charset="0"/>
+                  <a:srgbClr val="2B2E3C"/>
+                </a:solidFill>
+                <a:latin typeface="Calibri" pitchFamily="34" charset="0"/>
                 <a:ea typeface="Open Sans" pitchFamily="34" charset="-122"/>
                 <a:cs typeface="Open Sans" pitchFamily="34" charset="-120"/>
               </a:rPr>
@@ -13420,7 +13420,7 @@
             <a:avLst/>
           </a:prstGeom>
           <a:solidFill>
-            <a:srgbClr val="2C3F42"/>
+            <a:srgbClr val="FFF8F0"/>
           </a:solidFill>
           <a:ln w="12700">
             <a:solidFill>
@@ -13461,9 +13461,9 @@
             <a:r>
               <a:rPr lang="en-US" sz="562" b="1" spc="100" kern="0" dirty="0">
                 <a:solidFill>
-                  <a:srgbClr val="E2C8B5"/>
-                </a:solidFill>
-                <a:latin typeface="Bitter" pitchFamily="34" charset="0"/>
+                  <a:srgbClr val="AF2C20"/>
+                </a:solidFill>
+                <a:latin typeface="Calibri" pitchFamily="34" charset="0"/>
                 <a:ea typeface="Bitter" pitchFamily="34" charset="-122"/>
                 <a:cs typeface="Bitter" pitchFamily="34" charset="-120"/>
               </a:rPr>
@@ -13531,7 +13531,7 @@
                 <a:solidFill>
                   <a:srgbClr val="2B2E3C"/>
                 </a:solidFill>
-                <a:latin typeface="Roboto" pitchFamily="34" charset="0"/>
+                <a:latin typeface="Calibri" pitchFamily="34" charset="0"/>
                 <a:ea typeface="Roboto" pitchFamily="34" charset="-122"/>
                 <a:cs typeface="Roboto" pitchFamily="34" charset="-120"/>
               </a:rPr>
@@ -13556,7 +13556,7 @@
             <a:avLst/>
           </a:prstGeom>
           <a:solidFill>
-            <a:srgbClr val="BD5030"/>
+            <a:srgbClr val="BD3022"/>
           </a:solidFill>
           <a:ln w="12700">
             <a:solidFill>
@@ -13597,9 +13597,9 @@
             <a:r>
               <a:rPr lang="en-US" sz="468" b="1" dirty="0">
                 <a:solidFill>
-                  <a:srgbClr val="FFFFFF"/>
-                </a:solidFill>
-                <a:latin typeface="Open Sans" pitchFamily="34" charset="0"/>
+                  <a:srgbClr val="2B2E3C"/>
+                </a:solidFill>
+                <a:latin typeface="Calibri" pitchFamily="34" charset="0"/>
                 <a:ea typeface="Open Sans" pitchFamily="34" charset="-122"/>
                 <a:cs typeface="Open Sans" pitchFamily="34" charset="-120"/>
               </a:rPr>
@@ -13665,9 +13665,9 @@
             <a:r>
               <a:rPr lang="en-US" sz="468" b="1" dirty="0">
                 <a:solidFill>
-                  <a:srgbClr val="FFFFFF"/>
-                </a:solidFill>
-                <a:latin typeface="Open Sans" pitchFamily="34" charset="0"/>
+                  <a:srgbClr val="2B2E3C"/>
+                </a:solidFill>
+                <a:latin typeface="Calibri" pitchFamily="34" charset="0"/>
                 <a:ea typeface="Open Sans" pitchFamily="34" charset="-122"/>
                 <a:cs typeface="Open Sans" pitchFamily="34" charset="-120"/>
               </a:rPr>
@@ -13735,7 +13735,7 @@
                 <a:solidFill>
                   <a:srgbClr val="2B2E3C"/>
                 </a:solidFill>
-                <a:latin typeface="Roboto" pitchFamily="34" charset="0"/>
+                <a:latin typeface="Calibri" pitchFamily="34" charset="0"/>
                 <a:ea typeface="Roboto" pitchFamily="34" charset="-122"/>
                 <a:cs typeface="Roboto" pitchFamily="34" charset="-120"/>
               </a:rPr>
@@ -13760,7 +13760,7 @@
             <a:avLst/>
           </a:prstGeom>
           <a:solidFill>
-            <a:srgbClr val="BD5030"/>
+            <a:srgbClr val="BD3022"/>
           </a:solidFill>
           <a:ln w="12700">
             <a:solidFill>
@@ -13801,9 +13801,9 @@
             <a:r>
               <a:rPr lang="en-US" sz="468" b="1" dirty="0">
                 <a:solidFill>
-                  <a:srgbClr val="FFFFFF"/>
-                </a:solidFill>
-                <a:latin typeface="Open Sans" pitchFamily="34" charset="0"/>
+                  <a:srgbClr val="2B2E3C"/>
+                </a:solidFill>
+                <a:latin typeface="Calibri" pitchFamily="34" charset="0"/>
                 <a:ea typeface="Open Sans" pitchFamily="34" charset="-122"/>
                 <a:cs typeface="Open Sans" pitchFamily="34" charset="-120"/>
               </a:rPr>
@@ -13869,9 +13869,9 @@
             <a:r>
               <a:rPr lang="en-US" sz="468" b="1" dirty="0">
                 <a:solidFill>
-                  <a:srgbClr val="FFFFFF"/>
-                </a:solidFill>
-                <a:latin typeface="Open Sans" pitchFamily="34" charset="0"/>
+                  <a:srgbClr val="2B2E3C"/>
+                </a:solidFill>
+                <a:latin typeface="Calibri" pitchFamily="34" charset="0"/>
                 <a:ea typeface="Open Sans" pitchFamily="34" charset="-122"/>
                 <a:cs typeface="Open Sans" pitchFamily="34" charset="-120"/>
               </a:rPr>
@@ -13896,7 +13896,7 @@
             <a:avLst/>
           </a:prstGeom>
           <a:solidFill>
-            <a:srgbClr val="2C3F42"/>
+            <a:srgbClr val="FFF8F0"/>
           </a:solidFill>
           <a:ln w="12700">
             <a:solidFill>
@@ -13937,9 +13937,9 @@
             <a:r>
               <a:rPr lang="en-US" sz="562" b="1" spc="100" kern="0" dirty="0">
                 <a:solidFill>
-                  <a:srgbClr val="E2C8B5"/>
-                </a:solidFill>
-                <a:latin typeface="Bitter" pitchFamily="34" charset="0"/>
+                  <a:srgbClr val="AF2C20"/>
+                </a:solidFill>
+                <a:latin typeface="Calibri" pitchFamily="34" charset="0"/>
                 <a:ea typeface="Bitter" pitchFamily="34" charset="-122"/>
                 <a:cs typeface="Bitter" pitchFamily="34" charset="-120"/>
               </a:rPr>
@@ -14007,7 +14007,7 @@
                 <a:solidFill>
                   <a:srgbClr val="2B2E3C"/>
                 </a:solidFill>
-                <a:latin typeface="Roboto" pitchFamily="34" charset="0"/>
+                <a:latin typeface="Calibri" pitchFamily="34" charset="0"/>
                 <a:ea typeface="Roboto" pitchFamily="34" charset="-122"/>
                 <a:cs typeface="Roboto" pitchFamily="34" charset="-120"/>
               </a:rPr>
@@ -14032,7 +14032,7 @@
             <a:avLst/>
           </a:prstGeom>
           <a:solidFill>
-            <a:srgbClr val="7F4F35"/>
+            <a:srgbClr val="AF2C20"/>
           </a:solidFill>
           <a:ln w="12700">
             <a:solidFill>
@@ -14073,9 +14073,9 @@
             <a:r>
               <a:rPr lang="en-US" sz="468" b="1" dirty="0">
                 <a:solidFill>
-                  <a:srgbClr val="FFFFFF"/>
-                </a:solidFill>
-                <a:latin typeface="Open Sans" pitchFamily="34" charset="0"/>
+                  <a:srgbClr val="2B2E3C"/>
+                </a:solidFill>
+                <a:latin typeface="Calibri" pitchFamily="34" charset="0"/>
                 <a:ea typeface="Open Sans" pitchFamily="34" charset="-122"/>
                 <a:cs typeface="Open Sans" pitchFamily="34" charset="-120"/>
               </a:rPr>
@@ -14141,9 +14141,9 @@
             <a:r>
               <a:rPr lang="en-US" sz="468" b="1" dirty="0">
                 <a:solidFill>
-                  <a:srgbClr val="FFFFFF"/>
-                </a:solidFill>
-                <a:latin typeface="Open Sans" pitchFamily="34" charset="0"/>
+                  <a:srgbClr val="2B2E3C"/>
+                </a:solidFill>
+                <a:latin typeface="Calibri" pitchFamily="34" charset="0"/>
                 <a:ea typeface="Open Sans" pitchFamily="34" charset="-122"/>
                 <a:cs typeface="Open Sans" pitchFamily="34" charset="-120"/>
               </a:rPr>
@@ -14168,7 +14168,7 @@
             <a:avLst/>
           </a:prstGeom>
           <a:solidFill>
-            <a:srgbClr val="F59700"/>
+            <a:srgbClr val="D73729"/>
           </a:solidFill>
           <a:ln w="12700">
             <a:solidFill>
@@ -14211,7 +14211,7 @@
                 <a:solidFill>
                   <a:srgbClr val="D73729"/>
                 </a:solidFill>
-                <a:latin typeface="Bitter" pitchFamily="34" charset="0"/>
+                <a:latin typeface="Calibri" pitchFamily="34" charset="0"/>
                 <a:ea typeface="Bitter" pitchFamily="34" charset="-122"/>
                 <a:cs typeface="Bitter" pitchFamily="34" charset="-120"/>
               </a:rPr>
@@ -14236,7 +14236,7 @@
             <a:avLst/>
           </a:prstGeom>
           <a:solidFill>
-            <a:srgbClr val="3D6B6F"/>
+            <a:srgbClr val="E2C8B5"/>
           </a:solidFill>
           <a:ln w="12700">
             <a:solidFill>
@@ -14279,7 +14279,7 @@
                 <a:solidFill>
                   <a:srgbClr val="2B2E3C"/>
                 </a:solidFill>
-                <a:latin typeface="Open Sans" pitchFamily="34" charset="0"/>
+                <a:latin typeface="Calibri" pitchFamily="34" charset="0"/>
                 <a:ea typeface="Open Sans" pitchFamily="34" charset="-122"/>
                 <a:cs typeface="Open Sans" pitchFamily="34" charset="-120"/>
               </a:rPr>
@@ -14347,7 +14347,7 @@
                 <a:solidFill>
                   <a:srgbClr val="2B2E3C"/>
                 </a:solidFill>
-                <a:latin typeface="Open Sans" pitchFamily="34" charset="0"/>
+                <a:latin typeface="Calibri" pitchFamily="34" charset="0"/>
                 <a:ea typeface="Open Sans" pitchFamily="34" charset="-122"/>
                 <a:cs typeface="Open Sans" pitchFamily="34" charset="-120"/>
               </a:rPr>
@@ -14415,7 +14415,7 @@
                 <a:solidFill>
                   <a:srgbClr val="2B2E3C"/>
                 </a:solidFill>
-                <a:latin typeface="Open Sans" pitchFamily="34" charset="0"/>
+                <a:latin typeface="Calibri" pitchFamily="34" charset="0"/>
                 <a:ea typeface="Open Sans" pitchFamily="34" charset="-122"/>
                 <a:cs typeface="Open Sans" pitchFamily="34" charset="-120"/>
               </a:rPr>
@@ -14440,7 +14440,7 @@
             <a:avLst/>
           </a:prstGeom>
           <a:solidFill>
-            <a:srgbClr val="7F1F17"/>
+            <a:srgbClr val="AF2C20"/>
           </a:solidFill>
           <a:ln w="12700">
             <a:solidFill>
@@ -14483,7 +14483,7 @@
                 <a:solidFill>
                   <a:srgbClr val="2B2E3C"/>
                 </a:solidFill>
-                <a:latin typeface="Open Sans" pitchFamily="34" charset="0"/>
+                <a:latin typeface="Calibri" pitchFamily="34" charset="0"/>
                 <a:ea typeface="Open Sans" pitchFamily="34" charset="-122"/>
                 <a:cs typeface="Open Sans" pitchFamily="34" charset="-120"/>
               </a:rPr>
@@ -14508,7 +14508,7 @@
             <a:avLst/>
           </a:prstGeom>
           <a:solidFill>
-            <a:srgbClr val="BD5030"/>
+            <a:srgbClr val="BD3022"/>
           </a:solidFill>
           <a:ln w="12700">
             <a:solidFill>
@@ -14551,7 +14551,7 @@
                 <a:solidFill>
                   <a:srgbClr val="2B2E3C"/>
                 </a:solidFill>
-                <a:latin typeface="Open Sans" pitchFamily="34" charset="0"/>
+                <a:latin typeface="Calibri" pitchFamily="34" charset="0"/>
                 <a:ea typeface="Open Sans" pitchFamily="34" charset="-122"/>
                 <a:cs typeface="Open Sans" pitchFamily="34" charset="-120"/>
               </a:rPr>
@@ -14619,7 +14619,7 @@
                 <a:solidFill>
                   <a:srgbClr val="2B2E3C"/>
                 </a:solidFill>
-                <a:latin typeface="Open Sans" pitchFamily="34" charset="0"/>
+                <a:latin typeface="Calibri" pitchFamily="34" charset="0"/>
                 <a:ea typeface="Open Sans" pitchFamily="34" charset="-122"/>
                 <a:cs typeface="Open Sans" pitchFamily="34" charset="-120"/>
               </a:rPr>
@@ -14656,9 +14656,9 @@
             <a:r>
               <a:rPr lang="en-US" sz="531" i="1" dirty="0">
                 <a:solidFill>
-                  <a:srgbClr val="64748B"/>
-                </a:solidFill>
-                <a:latin typeface="Open Sans" pitchFamily="34" charset="0"/>
+                  <a:srgbClr val="2B2E3C"/>
+                </a:solidFill>
+                <a:latin typeface="Calibri" pitchFamily="34" charset="0"/>
                 <a:ea typeface="Open Sans" pitchFamily="34" charset="-122"/>
                 <a:cs typeface="Open Sans" pitchFamily="34" charset="-120"/>
               </a:rPr>
@@ -14715,7 +14715,7 @@
             <a:avLst/>
           </a:prstGeom>
           <a:solidFill>
-            <a:srgbClr val="2C3F42"/>
+            <a:srgbClr val="FFF8F0"/>
           </a:solidFill>
           <a:ln w="12700">
             <a:solidFill>
@@ -14756,9 +14756,9 @@
             <a:r>
               <a:rPr lang="en-US" sz="531" b="1" spc="300" kern="0" dirty="0">
                 <a:solidFill>
-                  <a:srgbClr val="E2C8B5"/>
-                </a:solidFill>
-                <a:latin typeface="Open Sans" pitchFamily="34" charset="0"/>
+                  <a:srgbClr val="AF2C20"/>
+                </a:solidFill>
+                <a:latin typeface="Calibri" pitchFamily="34" charset="0"/>
                 <a:ea typeface="Open Sans" pitchFamily="34" charset="-122"/>
                 <a:cs typeface="Open Sans" pitchFamily="34" charset="-120"/>
               </a:rPr>
@@ -14795,9 +14795,9 @@
             <a:r>
               <a:rPr lang="en-US" sz="1500" b="1" dirty="0">
                 <a:solidFill>
-                  <a:srgbClr val="FFFFFF"/>
-                </a:solidFill>
-                <a:latin typeface="Bitter" pitchFamily="34" charset="0"/>
+                  <a:srgbClr val="2B2E3C"/>
+                </a:solidFill>
+                <a:latin typeface="Calibri" pitchFamily="34" charset="0"/>
                 <a:ea typeface="Bitter" pitchFamily="34" charset="-122"/>
                 <a:cs typeface="Bitter" pitchFamily="34" charset="-120"/>
               </a:rPr>
@@ -14851,7 +14851,7 @@
             <a:avLst/>
           </a:prstGeom>
           <a:solidFill>
-            <a:srgbClr val="2C3F42"/>
+            <a:srgbClr val="FFF8F0"/>
           </a:solidFill>
           <a:ln w="12700">
             <a:solidFill>
@@ -14892,9 +14892,9 @@
             <a:r>
               <a:rPr lang="en-US" sz="937" b="1" dirty="0">
                 <a:solidFill>
-                  <a:srgbClr val="FFFFFF"/>
-                </a:solidFill>
-                <a:latin typeface="Bitter" pitchFamily="34" charset="0"/>
+                  <a:srgbClr val="2B2E3C"/>
+                </a:solidFill>
+                <a:latin typeface="Calibri" pitchFamily="34" charset="0"/>
                 <a:ea typeface="Bitter" pitchFamily="34" charset="-122"/>
                 <a:cs typeface="Bitter" pitchFamily="34" charset="-120"/>
               </a:rPr>
@@ -14931,9 +14931,9 @@
             <a:r>
               <a:rPr lang="en-US" sz="625" dirty="0">
                 <a:solidFill>
-                  <a:srgbClr val="FFFFFF"/>
-                </a:solidFill>
-                <a:latin typeface="Roboto" pitchFamily="34" charset="0"/>
+                  <a:srgbClr val="2B2E3C"/>
+                </a:solidFill>
+                <a:latin typeface="Calibri" pitchFamily="34" charset="0"/>
                 <a:ea typeface="Roboto" pitchFamily="34" charset="-122"/>
                 <a:cs typeface="Roboto" pitchFamily="34" charset="-120"/>
               </a:rPr>
@@ -14958,7 +14958,7 @@
             <a:avLst/>
           </a:prstGeom>
           <a:solidFill>
-            <a:srgbClr val="2C3F42"/>
+            <a:srgbClr val="FFF8F0"/>
           </a:solidFill>
           <a:ln w="12700">
             <a:solidFill>
@@ -15001,7 +15001,7 @@
                 <a:solidFill>
                   <a:srgbClr val="2B2E3C"/>
                 </a:solidFill>
-                <a:latin typeface="Roboto" pitchFamily="34" charset="0"/>
+                <a:latin typeface="Calibri" pitchFamily="34" charset="0"/>
                 <a:ea typeface="Roboto" pitchFamily="34" charset="-122"/>
                 <a:cs typeface="Roboto" pitchFamily="34" charset="-120"/>
               </a:rPr>
@@ -15026,7 +15026,7 @@
             <a:avLst/>
           </a:prstGeom>
           <a:solidFill>
-            <a:srgbClr val="2C3F42"/>
+            <a:srgbClr val="FFF8F0"/>
           </a:solidFill>
           <a:ln w="12700">
             <a:solidFill>
@@ -15069,7 +15069,7 @@
                 <a:solidFill>
                   <a:srgbClr val="2B2E3C"/>
                 </a:solidFill>
-                <a:latin typeface="Roboto" pitchFamily="34" charset="0"/>
+                <a:latin typeface="Calibri" pitchFamily="34" charset="0"/>
                 <a:ea typeface="Roboto" pitchFamily="34" charset="-122"/>
                 <a:cs typeface="Roboto" pitchFamily="34" charset="-120"/>
               </a:rPr>
@@ -15094,7 +15094,7 @@
             <a:avLst/>
           </a:prstGeom>
           <a:solidFill>
-            <a:srgbClr val="2C3F42"/>
+            <a:srgbClr val="FFF8F0"/>
           </a:solidFill>
           <a:ln w="12700">
             <a:solidFill>
@@ -15137,7 +15137,7 @@
                 <a:solidFill>
                   <a:srgbClr val="2B2E3C"/>
                 </a:solidFill>
-                <a:latin typeface="Roboto" pitchFamily="34" charset="0"/>
+                <a:latin typeface="Calibri" pitchFamily="34" charset="0"/>
                 <a:ea typeface="Roboto" pitchFamily="34" charset="-122"/>
                 <a:cs typeface="Roboto" pitchFamily="34" charset="-120"/>
               </a:rPr>
@@ -15162,7 +15162,7 @@
             <a:avLst/>
           </a:prstGeom>
           <a:solidFill>
-            <a:srgbClr val="2C3F42"/>
+            <a:srgbClr val="FFF8F0"/>
           </a:solidFill>
           <a:ln w="12700">
             <a:solidFill>
@@ -15205,7 +15205,7 @@
                 <a:solidFill>
                   <a:srgbClr val="2B2E3C"/>
                 </a:solidFill>
-                <a:latin typeface="Roboto" pitchFamily="34" charset="0"/>
+                <a:latin typeface="Calibri" pitchFamily="34" charset="0"/>
                 <a:ea typeface="Roboto" pitchFamily="34" charset="-122"/>
                 <a:cs typeface="Roboto" pitchFamily="34" charset="-120"/>
               </a:rPr>
@@ -15300,9 +15300,9 @@
             <a:r>
               <a:rPr lang="en-US" sz="937" b="1" dirty="0">
                 <a:solidFill>
-                  <a:srgbClr val="FFFFFF"/>
-                </a:solidFill>
-                <a:latin typeface="Bitter" pitchFamily="34" charset="0"/>
+                  <a:srgbClr val="2B2E3C"/>
+                </a:solidFill>
+                <a:latin typeface="Calibri" pitchFamily="34" charset="0"/>
                 <a:ea typeface="Bitter" pitchFamily="34" charset="-122"/>
                 <a:cs typeface="Bitter" pitchFamily="34" charset="-120"/>
               </a:rPr>
@@ -15339,9 +15339,9 @@
             <a:r>
               <a:rPr lang="en-US" sz="625" dirty="0">
                 <a:solidFill>
-                  <a:srgbClr val="FFFFFF"/>
-                </a:solidFill>
-                <a:latin typeface="Roboto" pitchFamily="34" charset="0"/>
+                  <a:srgbClr val="2B2E3C"/>
+                </a:solidFill>
+                <a:latin typeface="Calibri" pitchFamily="34" charset="0"/>
                 <a:ea typeface="Roboto" pitchFamily="34" charset="-122"/>
                 <a:cs typeface="Roboto" pitchFamily="34" charset="-120"/>
               </a:rPr>
@@ -15409,7 +15409,7 @@
                 <a:solidFill>
                   <a:srgbClr val="2B2E3C"/>
                 </a:solidFill>
-                <a:latin typeface="Roboto" pitchFamily="34" charset="0"/>
+                <a:latin typeface="Calibri" pitchFamily="34" charset="0"/>
                 <a:ea typeface="Roboto" pitchFamily="34" charset="-122"/>
                 <a:cs typeface="Roboto" pitchFamily="34" charset="-120"/>
               </a:rPr>
@@ -15477,7 +15477,7 @@
                 <a:solidFill>
                   <a:srgbClr val="2B2E3C"/>
                 </a:solidFill>
-                <a:latin typeface="Roboto" pitchFamily="34" charset="0"/>
+                <a:latin typeface="Calibri" pitchFamily="34" charset="0"/>
                 <a:ea typeface="Roboto" pitchFamily="34" charset="-122"/>
                 <a:cs typeface="Roboto" pitchFamily="34" charset="-120"/>
               </a:rPr>
@@ -15545,7 +15545,7 @@
                 <a:solidFill>
                   <a:srgbClr val="2B2E3C"/>
                 </a:solidFill>
-                <a:latin typeface="Roboto" pitchFamily="34" charset="0"/>
+                <a:latin typeface="Calibri" pitchFamily="34" charset="0"/>
                 <a:ea typeface="Roboto" pitchFamily="34" charset="-122"/>
                 <a:cs typeface="Roboto" pitchFamily="34" charset="-120"/>
               </a:rPr>
@@ -15613,7 +15613,7 @@
                 <a:solidFill>
                   <a:srgbClr val="2B2E3C"/>
                 </a:solidFill>
-                <a:latin typeface="Roboto" pitchFamily="34" charset="0"/>
+                <a:latin typeface="Calibri" pitchFamily="34" charset="0"/>
                 <a:ea typeface="Roboto" pitchFamily="34" charset="-122"/>
                 <a:cs typeface="Roboto" pitchFamily="34" charset="-120"/>
               </a:rPr>
@@ -15708,9 +15708,9 @@
             <a:r>
               <a:rPr lang="en-US" sz="937" b="1" dirty="0">
                 <a:solidFill>
-                  <a:srgbClr val="FFFFFF"/>
-                </a:solidFill>
-                <a:latin typeface="Bitter" pitchFamily="34" charset="0"/>
+                  <a:srgbClr val="2B2E3C"/>
+                </a:solidFill>
+                <a:latin typeface="Calibri" pitchFamily="34" charset="0"/>
                 <a:ea typeface="Bitter" pitchFamily="34" charset="-122"/>
                 <a:cs typeface="Bitter" pitchFamily="34" charset="-120"/>
               </a:rPr>
@@ -15747,9 +15747,9 @@
             <a:r>
               <a:rPr lang="en-US" sz="625" dirty="0">
                 <a:solidFill>
-                  <a:srgbClr val="FFFFFF"/>
-                </a:solidFill>
-                <a:latin typeface="Roboto" pitchFamily="34" charset="0"/>
+                  <a:srgbClr val="2B2E3C"/>
+                </a:solidFill>
+                <a:latin typeface="Calibri" pitchFamily="34" charset="0"/>
                 <a:ea typeface="Roboto" pitchFamily="34" charset="-122"/>
                 <a:cs typeface="Roboto" pitchFamily="34" charset="-120"/>
               </a:rPr>
@@ -15817,7 +15817,7 @@
                 <a:solidFill>
                   <a:srgbClr val="2B2E3C"/>
                 </a:solidFill>
-                <a:latin typeface="Roboto" pitchFamily="34" charset="0"/>
+                <a:latin typeface="Calibri" pitchFamily="34" charset="0"/>
                 <a:ea typeface="Roboto" pitchFamily="34" charset="-122"/>
                 <a:cs typeface="Roboto" pitchFamily="34" charset="-120"/>
               </a:rPr>
@@ -15885,7 +15885,7 @@
                 <a:solidFill>
                   <a:srgbClr val="2B2E3C"/>
                 </a:solidFill>
-                <a:latin typeface="Roboto" pitchFamily="34" charset="0"/>
+                <a:latin typeface="Calibri" pitchFamily="34" charset="0"/>
                 <a:ea typeface="Roboto" pitchFamily="34" charset="-122"/>
                 <a:cs typeface="Roboto" pitchFamily="34" charset="-120"/>
               </a:rPr>
@@ -15953,7 +15953,7 @@
                 <a:solidFill>
                   <a:srgbClr val="2B2E3C"/>
                 </a:solidFill>
-                <a:latin typeface="Roboto" pitchFamily="34" charset="0"/>
+                <a:latin typeface="Calibri" pitchFamily="34" charset="0"/>
                 <a:ea typeface="Roboto" pitchFamily="34" charset="-122"/>
                 <a:cs typeface="Roboto" pitchFamily="34" charset="-120"/>
               </a:rPr>
@@ -16021,7 +16021,7 @@
                 <a:solidFill>
                   <a:srgbClr val="2B2E3C"/>
                 </a:solidFill>
-                <a:latin typeface="Roboto" pitchFamily="34" charset="0"/>
+                <a:latin typeface="Calibri" pitchFamily="34" charset="0"/>
                 <a:ea typeface="Roboto" pitchFamily="34" charset="-122"/>
                 <a:cs typeface="Roboto" pitchFamily="34" charset="-120"/>
               </a:rPr>
@@ -16058,9 +16058,9 @@
             <a:r>
               <a:rPr lang="en-US" sz="531" i="1" dirty="0">
                 <a:solidFill>
-                  <a:srgbClr val="64748B"/>
-                </a:solidFill>
-                <a:latin typeface="Open Sans" pitchFamily="34" charset="0"/>
+                  <a:srgbClr val="2B2E3C"/>
+                </a:solidFill>
+                <a:latin typeface="Calibri" pitchFamily="34" charset="0"/>
                 <a:ea typeface="Open Sans" pitchFamily="34" charset="-122"/>
                 <a:cs typeface="Open Sans" pitchFamily="34" charset="-120"/>
               </a:rPr>
@@ -16117,7 +16117,7 @@
             <a:avLst/>
           </a:prstGeom>
           <a:solidFill>
-            <a:srgbClr val="2C3F42"/>
+            <a:srgbClr val="FFF8F0"/>
           </a:solidFill>
           <a:ln w="12700">
             <a:solidFill>
@@ -16158,9 +16158,9 @@
             <a:r>
               <a:rPr lang="en-US" sz="531" b="1" spc="300" kern="0" dirty="0">
                 <a:solidFill>
-                  <a:srgbClr val="E2C8B5"/>
-                </a:solidFill>
-                <a:latin typeface="Open Sans" pitchFamily="34" charset="0"/>
+                  <a:srgbClr val="AF2C20"/>
+                </a:solidFill>
+                <a:latin typeface="Calibri" pitchFamily="34" charset="0"/>
                 <a:ea typeface="Open Sans" pitchFamily="34" charset="-122"/>
                 <a:cs typeface="Open Sans" pitchFamily="34" charset="-120"/>
               </a:rPr>
@@ -16197,9 +16197,9 @@
             <a:r>
               <a:rPr lang="en-US" sz="1500" b="1" dirty="0">
                 <a:solidFill>
-                  <a:srgbClr val="FFFFFF"/>
-                </a:solidFill>
-                <a:latin typeface="Bitter" pitchFamily="34" charset="0"/>
+                  <a:srgbClr val="2B2E3C"/>
+                </a:solidFill>
+                <a:latin typeface="Calibri" pitchFamily="34" charset="0"/>
                 <a:ea typeface="Bitter" pitchFamily="34" charset="-122"/>
                 <a:cs typeface="Bitter" pitchFamily="34" charset="-120"/>
               </a:rPr>
@@ -16236,9 +16236,9 @@
             <a:r>
               <a:rPr lang="en-US" sz="687" i="1" dirty="0">
                 <a:solidFill>
-                  <a:srgbClr val="334155"/>
-                </a:solidFill>
-                <a:latin typeface="Roboto" pitchFamily="34" charset="0"/>
+                  <a:srgbClr val="2B2E3C"/>
+                </a:solidFill>
+                <a:latin typeface="Calibri" pitchFamily="34" charset="0"/>
                 <a:ea typeface="Roboto" pitchFamily="34" charset="-122"/>
                 <a:cs typeface="Roboto" pitchFamily="34" charset="-120"/>
               </a:rPr>
@@ -16263,7 +16263,7 @@
             <a:avLst/>
           </a:prstGeom>
           <a:solidFill>
-            <a:srgbClr val="2C3F42"/>
+            <a:srgbClr val="FFF8F0"/>
           </a:solidFill>
           <a:ln w="12700">
             <a:solidFill>
@@ -16304,9 +16304,9 @@
             <a:r>
               <a:rPr lang="en-US" sz="687" b="1" dirty="0">
                 <a:solidFill>
-                  <a:srgbClr val="FFFFFF"/>
-                </a:solidFill>
-                <a:latin typeface="Bitter" pitchFamily="34" charset="0"/>
+                  <a:srgbClr val="2B2E3C"/>
+                </a:solidFill>
+                <a:latin typeface="Calibri" pitchFamily="34" charset="0"/>
                 <a:ea typeface="Bitter" pitchFamily="34" charset="-122"/>
                 <a:cs typeface="Bitter" pitchFamily="34" charset="-120"/>
               </a:rPr>
@@ -16331,7 +16331,7 @@
             <a:avLst/>
           </a:prstGeom>
           <a:solidFill>
-            <a:srgbClr val="2C3F42"/>
+            <a:srgbClr val="FFF8F0"/>
           </a:solidFill>
           <a:ln w="12700">
             <a:solidFill>
@@ -16372,9 +16372,9 @@
             <a:r>
               <a:rPr lang="en-US" sz="687" b="1" dirty="0">
                 <a:solidFill>
-                  <a:srgbClr val="FFFFFF"/>
-                </a:solidFill>
-                <a:latin typeface="Bitter" pitchFamily="34" charset="0"/>
+                  <a:srgbClr val="2B2E3C"/>
+                </a:solidFill>
+                <a:latin typeface="Calibri" pitchFamily="34" charset="0"/>
                 <a:ea typeface="Bitter" pitchFamily="34" charset="-122"/>
                 <a:cs typeface="Bitter" pitchFamily="34" charset="-120"/>
               </a:rPr>
@@ -16399,7 +16399,7 @@
             <a:avLst/>
           </a:prstGeom>
           <a:solidFill>
-            <a:srgbClr val="2C3F42"/>
+            <a:srgbClr val="FFF8F0"/>
           </a:solidFill>
           <a:ln w="12700">
             <a:solidFill>
@@ -16440,9 +16440,9 @@
             <a:r>
               <a:rPr lang="en-US" sz="687" b="1" dirty="0">
                 <a:solidFill>
-                  <a:srgbClr val="FFFFFF"/>
-                </a:solidFill>
-                <a:latin typeface="Bitter" pitchFamily="34" charset="0"/>
+                  <a:srgbClr val="2B2E3C"/>
+                </a:solidFill>
+                <a:latin typeface="Calibri" pitchFamily="34" charset="0"/>
                 <a:ea typeface="Bitter" pitchFamily="34" charset="-122"/>
                 <a:cs typeface="Bitter" pitchFamily="34" charset="-120"/>
               </a:rPr>
@@ -16467,7 +16467,7 @@
             <a:avLst/>
           </a:prstGeom>
           <a:solidFill>
-            <a:srgbClr val="2C3F42"/>
+            <a:srgbClr val="FFF8F0"/>
           </a:solidFill>
           <a:ln w="12700">
             <a:solidFill>
@@ -16508,9 +16508,9 @@
             <a:r>
               <a:rPr lang="en-US" sz="687" b="1" dirty="0">
                 <a:solidFill>
-                  <a:srgbClr val="FFFFFF"/>
-                </a:solidFill>
-                <a:latin typeface="Bitter" pitchFamily="34" charset="0"/>
+                  <a:srgbClr val="2B2E3C"/>
+                </a:solidFill>
+                <a:latin typeface="Calibri" pitchFamily="34" charset="0"/>
                 <a:ea typeface="Bitter" pitchFamily="34" charset="-122"/>
                 <a:cs typeface="Bitter" pitchFamily="34" charset="-120"/>
               </a:rPr>
@@ -16651,7 +16651,7 @@
             <a:avLst/>
           </a:prstGeom>
           <a:solidFill>
-            <a:srgbClr val="2C3F42"/>
+            <a:srgbClr val="FFF8F0"/>
           </a:solidFill>
           <a:ln w="12700">
             <a:solidFill>
@@ -16692,9 +16692,9 @@
             <a:r>
               <a:rPr lang="en-US" sz="593" b="1" dirty="0">
                 <a:solidFill>
-                  <a:srgbClr val="FFFFFF"/>
-                </a:solidFill>
-                <a:latin typeface="Bitter" pitchFamily="34" charset="0"/>
+                  <a:srgbClr val="2B2E3C"/>
+                </a:solidFill>
+                <a:latin typeface="Calibri" pitchFamily="34" charset="0"/>
                 <a:ea typeface="Bitter" pitchFamily="34" charset="-122"/>
                 <a:cs typeface="Bitter" pitchFamily="34" charset="-120"/>
               </a:rPr>
@@ -16733,7 +16733,7 @@
                 <a:solidFill>
                   <a:srgbClr val="2B2E3C"/>
                 </a:solidFill>
-                <a:latin typeface="Bitter" pitchFamily="34" charset="0"/>
+                <a:latin typeface="Calibri" pitchFamily="34" charset="0"/>
                 <a:ea typeface="Bitter" pitchFamily="34" charset="-122"/>
                 <a:cs typeface="Bitter" pitchFamily="34" charset="-120"/>
               </a:rPr>
@@ -16772,7 +16772,7 @@
                 <a:solidFill>
                   <a:srgbClr val="BD3022"/>
                 </a:solidFill>
-                <a:latin typeface="Roboto" pitchFamily="34" charset="0"/>
+                <a:latin typeface="Calibri" pitchFamily="34" charset="0"/>
                 <a:ea typeface="Roboto" pitchFamily="34" charset="-122"/>
                 <a:cs typeface="Roboto" pitchFamily="34" charset="-120"/>
               </a:rPr>
@@ -16809,9 +16809,9 @@
             <a:r>
               <a:rPr lang="en-US" sz="656" dirty="0">
                 <a:solidFill>
-                  <a:srgbClr val="334155"/>
-                </a:solidFill>
-                <a:latin typeface="Roboto" pitchFamily="34" charset="0"/>
+                  <a:srgbClr val="2B2E3C"/>
+                </a:solidFill>
+                <a:latin typeface="Calibri" pitchFamily="34" charset="0"/>
                 <a:ea typeface="Roboto" pitchFamily="34" charset="-122"/>
                 <a:cs typeface="Roboto" pitchFamily="34" charset="-120"/>
               </a:rPr>
@@ -16836,7 +16836,7 @@
             <a:avLst/>
           </a:prstGeom>
           <a:solidFill>
-            <a:srgbClr val="F9FAFD"/>
+            <a:srgbClr val="FFFFFF"/>
           </a:solidFill>
           <a:ln w="12700">
             <a:solidFill>
@@ -16865,7 +16865,7 @@
             <a:avLst/>
           </a:prstGeom>
           <a:solidFill>
-            <a:srgbClr val="F9FAFD"/>
+            <a:srgbClr val="FFFFFF"/>
           </a:solidFill>
           <a:ln w="12700">
             <a:solidFill>
@@ -16894,7 +16894,7 @@
             <a:avLst/>
           </a:prstGeom>
           <a:solidFill>
-            <a:srgbClr val="F9FAFD"/>
+            <a:srgbClr val="FFFFFF"/>
           </a:solidFill>
           <a:ln w="12700">
             <a:solidFill>
@@ -16923,7 +16923,7 @@
             <a:avLst/>
           </a:prstGeom>
           <a:solidFill>
-            <a:srgbClr val="F9FAFD"/>
+            <a:srgbClr val="FFFFFF"/>
           </a:solidFill>
           <a:ln w="12700">
             <a:solidFill>
@@ -16952,7 +16952,7 @@
             <a:avLst/>
           </a:prstGeom>
           <a:solidFill>
-            <a:srgbClr val="2C3F42"/>
+            <a:srgbClr val="FFF8F0"/>
           </a:solidFill>
           <a:ln w="12700">
             <a:solidFill>
@@ -16993,9 +16993,9 @@
             <a:r>
               <a:rPr lang="en-US" sz="593" b="1" dirty="0">
                 <a:solidFill>
-                  <a:srgbClr val="FFFFFF"/>
-                </a:solidFill>
-                <a:latin typeface="Bitter" pitchFamily="34" charset="0"/>
+                  <a:srgbClr val="2B2E3C"/>
+                </a:solidFill>
+                <a:latin typeface="Calibri" pitchFamily="34" charset="0"/>
                 <a:ea typeface="Bitter" pitchFamily="34" charset="-122"/>
                 <a:cs typeface="Bitter" pitchFamily="34" charset="-120"/>
               </a:rPr>
@@ -17034,7 +17034,7 @@
                 <a:solidFill>
                   <a:srgbClr val="2B2E3C"/>
                 </a:solidFill>
-                <a:latin typeface="Bitter" pitchFamily="34" charset="0"/>
+                <a:latin typeface="Calibri" pitchFamily="34" charset="0"/>
                 <a:ea typeface="Bitter" pitchFamily="34" charset="-122"/>
                 <a:cs typeface="Bitter" pitchFamily="34" charset="-120"/>
               </a:rPr>
@@ -17073,7 +17073,7 @@
                 <a:solidFill>
                   <a:srgbClr val="BD3022"/>
                 </a:solidFill>
-                <a:latin typeface="Roboto" pitchFamily="34" charset="0"/>
+                <a:latin typeface="Calibri" pitchFamily="34" charset="0"/>
                 <a:ea typeface="Roboto" pitchFamily="34" charset="-122"/>
                 <a:cs typeface="Roboto" pitchFamily="34" charset="-120"/>
               </a:rPr>
@@ -17110,9 +17110,9 @@
             <a:r>
               <a:rPr lang="en-US" sz="656" dirty="0">
                 <a:solidFill>
-                  <a:srgbClr val="334155"/>
-                </a:solidFill>
-                <a:latin typeface="Roboto" pitchFamily="34" charset="0"/>
+                  <a:srgbClr val="2B2E3C"/>
+                </a:solidFill>
+                <a:latin typeface="Calibri" pitchFamily="34" charset="0"/>
                 <a:ea typeface="Roboto" pitchFamily="34" charset="-122"/>
                 <a:cs typeface="Roboto" pitchFamily="34" charset="-120"/>
               </a:rPr>
@@ -17294,9 +17294,9 @@
             <a:r>
               <a:rPr lang="en-US" sz="593" b="1" dirty="0">
                 <a:solidFill>
-                  <a:srgbClr val="FFFFFF"/>
-                </a:solidFill>
-                <a:latin typeface="Bitter" pitchFamily="34" charset="0"/>
+                  <a:srgbClr val="2B2E3C"/>
+                </a:solidFill>
+                <a:latin typeface="Calibri" pitchFamily="34" charset="0"/>
                 <a:ea typeface="Bitter" pitchFamily="34" charset="-122"/>
                 <a:cs typeface="Bitter" pitchFamily="34" charset="-120"/>
               </a:rPr>
@@ -17335,7 +17335,7 @@
                 <a:solidFill>
                   <a:srgbClr val="2B2E3C"/>
                 </a:solidFill>
-                <a:latin typeface="Bitter" pitchFamily="34" charset="0"/>
+                <a:latin typeface="Calibri" pitchFamily="34" charset="0"/>
                 <a:ea typeface="Bitter" pitchFamily="34" charset="-122"/>
                 <a:cs typeface="Bitter" pitchFamily="34" charset="-120"/>
               </a:rPr>
@@ -17374,7 +17374,7 @@
                 <a:solidFill>
                   <a:srgbClr val="BD3022"/>
                 </a:solidFill>
-                <a:latin typeface="Roboto" pitchFamily="34" charset="0"/>
+                <a:latin typeface="Calibri" pitchFamily="34" charset="0"/>
                 <a:ea typeface="Roboto" pitchFamily="34" charset="-122"/>
                 <a:cs typeface="Roboto" pitchFamily="34" charset="-120"/>
               </a:rPr>
@@ -17411,9 +17411,9 @@
             <a:r>
               <a:rPr lang="en-US" sz="656" dirty="0">
                 <a:solidFill>
-                  <a:srgbClr val="334155"/>
-                </a:solidFill>
-                <a:latin typeface="Roboto" pitchFamily="34" charset="0"/>
+                  <a:srgbClr val="2B2E3C"/>
+                </a:solidFill>
+                <a:latin typeface="Calibri" pitchFamily="34" charset="0"/>
                 <a:ea typeface="Roboto" pitchFamily="34" charset="-122"/>
                 <a:cs typeface="Roboto" pitchFamily="34" charset="-120"/>
               </a:rPr>
@@ -17438,7 +17438,7 @@
             <a:avLst/>
           </a:prstGeom>
           <a:solidFill>
-            <a:srgbClr val="F9FAFD"/>
+            <a:srgbClr val="FFFFFF"/>
           </a:solidFill>
           <a:ln w="12700">
             <a:solidFill>
@@ -17467,7 +17467,7 @@
             <a:avLst/>
           </a:prstGeom>
           <a:solidFill>
-            <a:srgbClr val="F9FAFD"/>
+            <a:srgbClr val="FFFFFF"/>
           </a:solidFill>
           <a:ln w="12700">
             <a:solidFill>
@@ -17496,7 +17496,7 @@
             <a:avLst/>
           </a:prstGeom>
           <a:solidFill>
-            <a:srgbClr val="F9FAFD"/>
+            <a:srgbClr val="FFFFFF"/>
           </a:solidFill>
           <a:ln w="12700">
             <a:solidFill>
@@ -17525,7 +17525,7 @@
             <a:avLst/>
           </a:prstGeom>
           <a:solidFill>
-            <a:srgbClr val="F9FAFD"/>
+            <a:srgbClr val="FFFFFF"/>
           </a:solidFill>
           <a:ln w="12700">
             <a:solidFill>
@@ -17595,9 +17595,9 @@
             <a:r>
               <a:rPr lang="en-US" sz="593" b="1" dirty="0">
                 <a:solidFill>
-                  <a:srgbClr val="FFFFFF"/>
-                </a:solidFill>
-                <a:latin typeface="Bitter" pitchFamily="34" charset="0"/>
+                  <a:srgbClr val="2B2E3C"/>
+                </a:solidFill>
+                <a:latin typeface="Calibri" pitchFamily="34" charset="0"/>
                 <a:ea typeface="Bitter" pitchFamily="34" charset="-122"/>
                 <a:cs typeface="Bitter" pitchFamily="34" charset="-120"/>
               </a:rPr>
@@ -17636,7 +17636,7 @@
                 <a:solidFill>
                   <a:srgbClr val="2B2E3C"/>
                 </a:solidFill>
-                <a:latin typeface="Bitter" pitchFamily="34" charset="0"/>
+                <a:latin typeface="Calibri" pitchFamily="34" charset="0"/>
                 <a:ea typeface="Bitter" pitchFamily="34" charset="-122"/>
                 <a:cs typeface="Bitter" pitchFamily="34" charset="-120"/>
               </a:rPr>
@@ -17675,7 +17675,7 @@
                 <a:solidFill>
                   <a:srgbClr val="BD3022"/>
                 </a:solidFill>
-                <a:latin typeface="Roboto" pitchFamily="34" charset="0"/>
+                <a:latin typeface="Calibri" pitchFamily="34" charset="0"/>
                 <a:ea typeface="Roboto" pitchFamily="34" charset="-122"/>
                 <a:cs typeface="Roboto" pitchFamily="34" charset="-120"/>
               </a:rPr>
@@ -17712,9 +17712,9 @@
             <a:r>
               <a:rPr lang="en-US" sz="656" dirty="0">
                 <a:solidFill>
-                  <a:srgbClr val="334155"/>
-                </a:solidFill>
-                <a:latin typeface="Roboto" pitchFamily="34" charset="0"/>
+                  <a:srgbClr val="2B2E3C"/>
+                </a:solidFill>
+                <a:latin typeface="Calibri" pitchFamily="34" charset="0"/>
                 <a:ea typeface="Roboto" pitchFamily="34" charset="-122"/>
                 <a:cs typeface="Roboto" pitchFamily="34" charset="-120"/>
               </a:rPr>
@@ -17896,9 +17896,9 @@
             <a:r>
               <a:rPr lang="en-US" sz="593" b="1" dirty="0">
                 <a:solidFill>
-                  <a:srgbClr val="FFFFFF"/>
-                </a:solidFill>
-                <a:latin typeface="Bitter" pitchFamily="34" charset="0"/>
+                  <a:srgbClr val="2B2E3C"/>
+                </a:solidFill>
+                <a:latin typeface="Calibri" pitchFamily="34" charset="0"/>
                 <a:ea typeface="Bitter" pitchFamily="34" charset="-122"/>
                 <a:cs typeface="Bitter" pitchFamily="34" charset="-120"/>
               </a:rPr>
@@ -17937,7 +17937,7 @@
                 <a:solidFill>
                   <a:srgbClr val="2B2E3C"/>
                 </a:solidFill>
-                <a:latin typeface="Bitter" pitchFamily="34" charset="0"/>
+                <a:latin typeface="Calibri" pitchFamily="34" charset="0"/>
                 <a:ea typeface="Bitter" pitchFamily="34" charset="-122"/>
                 <a:cs typeface="Bitter" pitchFamily="34" charset="-120"/>
               </a:rPr>
@@ -17976,7 +17976,7 @@
                 <a:solidFill>
                   <a:srgbClr val="BD3022"/>
                 </a:solidFill>
-                <a:latin typeface="Roboto" pitchFamily="34" charset="0"/>
+                <a:latin typeface="Calibri" pitchFamily="34" charset="0"/>
                 <a:ea typeface="Roboto" pitchFamily="34" charset="-122"/>
                 <a:cs typeface="Roboto" pitchFamily="34" charset="-120"/>
               </a:rPr>
@@ -18013,9 +18013,9 @@
             <a:r>
               <a:rPr lang="en-US" sz="656" dirty="0">
                 <a:solidFill>
-                  <a:srgbClr val="334155"/>
-                </a:solidFill>
-                <a:latin typeface="Roboto" pitchFamily="34" charset="0"/>
+                  <a:srgbClr val="2B2E3C"/>
+                </a:solidFill>
+                <a:latin typeface="Calibri" pitchFamily="34" charset="0"/>
                 <a:ea typeface="Roboto" pitchFamily="34" charset="-122"/>
                 <a:cs typeface="Roboto" pitchFamily="34" charset="-120"/>
               </a:rPr>
@@ -18114,7 +18114,7 @@
                 <a:solidFill>
                   <a:srgbClr val="2B2E3C"/>
                 </a:solidFill>
-                <a:latin typeface="Roboto" pitchFamily="34" charset="0"/>
+                <a:latin typeface="Calibri" pitchFamily="34" charset="0"/>
                 <a:ea typeface="Roboto" pitchFamily="34" charset="-122"/>
                 <a:cs typeface="Roboto" pitchFamily="34" charset="-120"/>
               </a:rPr>
@@ -18204,7 +18204,7 @@
             <a:avLst/>
           </a:prstGeom>
           <a:solidFill>
-            <a:srgbClr val="243539"/>
+            <a:srgbClr val="FFF8F0"/>
           </a:solidFill>
           <a:ln w="12700">
             <a:solidFill>
@@ -18274,9 +18274,9 @@
             <a:r>
               <a:rPr lang="en-US" sz="687" b="1" spc="300" kern="0" dirty="0">
                 <a:solidFill>
-                  <a:srgbClr val="E2C8B5"/>
-                </a:solidFill>
-                <a:latin typeface="Open Sans" pitchFamily="34" charset="0"/>
+                  <a:srgbClr val="AF2C20"/>
+                </a:solidFill>
+                <a:latin typeface="Calibri" pitchFamily="34" charset="0"/>
                 <a:ea typeface="Open Sans" pitchFamily="34" charset="-122"/>
                 <a:cs typeface="Open Sans" pitchFamily="34" charset="-120"/>
               </a:rPr>
@@ -18313,9 +18313,9 @@
             <a:r>
               <a:rPr lang="en-US" sz="1250" b="1" dirty="0">
                 <a:solidFill>
-                  <a:srgbClr val="FFFFFF"/>
-                </a:solidFill>
-                <a:latin typeface="Bitter" pitchFamily="34" charset="0"/>
+                  <a:srgbClr val="2B2E3C"/>
+                </a:solidFill>
+                <a:latin typeface="Calibri" pitchFamily="34" charset="0"/>
                 <a:ea typeface="Bitter" pitchFamily="34" charset="-122"/>
                 <a:cs typeface="Bitter" pitchFamily="34" charset="-120"/>
               </a:rPr>
@@ -18381,9 +18381,9 @@
             <a:r>
               <a:rPr lang="en-US" sz="875" b="1" dirty="0">
                 <a:solidFill>
-                  <a:srgbClr val="FFFFFF"/>
-                </a:solidFill>
-                <a:latin typeface="Bitter" pitchFamily="34" charset="0"/>
+                  <a:srgbClr val="2B2E3C"/>
+                </a:solidFill>
+                <a:latin typeface="Calibri" pitchFamily="34" charset="0"/>
                 <a:ea typeface="Bitter" pitchFamily="34" charset="-122"/>
                 <a:cs typeface="Bitter" pitchFamily="34" charset="-120"/>
               </a:rPr>
@@ -18420,9 +18420,9 @@
             <a:r>
               <a:rPr lang="en-US" sz="812" b="1" dirty="0">
                 <a:solidFill>
-                  <a:srgbClr val="FFFFFF"/>
-                </a:solidFill>
-                <a:latin typeface="Bitter" pitchFamily="34" charset="0"/>
+                  <a:srgbClr val="2B2E3C"/>
+                </a:solidFill>
+                <a:latin typeface="Calibri" pitchFamily="34" charset="0"/>
                 <a:ea typeface="Bitter" pitchFamily="34" charset="-122"/>
                 <a:cs typeface="Bitter" pitchFamily="34" charset="-120"/>
               </a:rPr>
@@ -18459,9 +18459,9 @@
             <a:r>
               <a:rPr lang="en-US" sz="656" dirty="0">
                 <a:solidFill>
-                  <a:srgbClr val="AABCB6"/>
-                </a:solidFill>
-                <a:latin typeface="Roboto" pitchFamily="34" charset="0"/>
+                  <a:srgbClr val="2B2E3C"/>
+                </a:solidFill>
+                <a:latin typeface="Calibri" pitchFamily="34" charset="0"/>
                 <a:ea typeface="Roboto" pitchFamily="34" charset="-122"/>
                 <a:cs typeface="Roboto" pitchFamily="34" charset="-120"/>
               </a:rPr>
@@ -18527,9 +18527,9 @@
             <a:r>
               <a:rPr lang="en-US" sz="875" b="1" dirty="0">
                 <a:solidFill>
-                  <a:srgbClr val="FFFFFF"/>
-                </a:solidFill>
-                <a:latin typeface="Bitter" pitchFamily="34" charset="0"/>
+                  <a:srgbClr val="2B2E3C"/>
+                </a:solidFill>
+                <a:latin typeface="Calibri" pitchFamily="34" charset="0"/>
                 <a:ea typeface="Bitter" pitchFamily="34" charset="-122"/>
                 <a:cs typeface="Bitter" pitchFamily="34" charset="-120"/>
               </a:rPr>
@@ -18566,9 +18566,9 @@
             <a:r>
               <a:rPr lang="en-US" sz="812" b="1" dirty="0">
                 <a:solidFill>
-                  <a:srgbClr val="FFFFFF"/>
-                </a:solidFill>
-                <a:latin typeface="Bitter" pitchFamily="34" charset="0"/>
+                  <a:srgbClr val="2B2E3C"/>
+                </a:solidFill>
+                <a:latin typeface="Calibri" pitchFamily="34" charset="0"/>
                 <a:ea typeface="Bitter" pitchFamily="34" charset="-122"/>
                 <a:cs typeface="Bitter" pitchFamily="34" charset="-120"/>
               </a:rPr>
@@ -18605,9 +18605,9 @@
             <a:r>
               <a:rPr lang="en-US" sz="656" dirty="0">
                 <a:solidFill>
-                  <a:srgbClr val="AABCB6"/>
-                </a:solidFill>
-                <a:latin typeface="Roboto" pitchFamily="34" charset="0"/>
+                  <a:srgbClr val="2B2E3C"/>
+                </a:solidFill>
+                <a:latin typeface="Calibri" pitchFamily="34" charset="0"/>
                 <a:ea typeface="Roboto" pitchFamily="34" charset="-122"/>
                 <a:cs typeface="Roboto" pitchFamily="34" charset="-120"/>
               </a:rPr>
@@ -18673,9 +18673,9 @@
             <a:r>
               <a:rPr lang="en-US" sz="875" b="1" dirty="0">
                 <a:solidFill>
-                  <a:srgbClr val="FFFFFF"/>
-                </a:solidFill>
-                <a:latin typeface="Bitter" pitchFamily="34" charset="0"/>
+                  <a:srgbClr val="2B2E3C"/>
+                </a:solidFill>
+                <a:latin typeface="Calibri" pitchFamily="34" charset="0"/>
                 <a:ea typeface="Bitter" pitchFamily="34" charset="-122"/>
                 <a:cs typeface="Bitter" pitchFamily="34" charset="-120"/>
               </a:rPr>
@@ -18712,9 +18712,9 @@
             <a:r>
               <a:rPr lang="en-US" sz="812" b="1" dirty="0">
                 <a:solidFill>
-                  <a:srgbClr val="FFFFFF"/>
-                </a:solidFill>
-                <a:latin typeface="Bitter" pitchFamily="34" charset="0"/>
+                  <a:srgbClr val="2B2E3C"/>
+                </a:solidFill>
+                <a:latin typeface="Calibri" pitchFamily="34" charset="0"/>
                 <a:ea typeface="Bitter" pitchFamily="34" charset="-122"/>
                 <a:cs typeface="Bitter" pitchFamily="34" charset="-120"/>
               </a:rPr>
@@ -18751,9 +18751,9 @@
             <a:r>
               <a:rPr lang="en-US" sz="656" dirty="0">
                 <a:solidFill>
-                  <a:srgbClr val="AABCB6"/>
-                </a:solidFill>
-                <a:latin typeface="Roboto" pitchFamily="34" charset="0"/>
+                  <a:srgbClr val="2B2E3C"/>
+                </a:solidFill>
+                <a:latin typeface="Calibri" pitchFamily="34" charset="0"/>
                 <a:ea typeface="Roboto" pitchFamily="34" charset="-122"/>
                 <a:cs typeface="Roboto" pitchFamily="34" charset="-120"/>
               </a:rPr>
@@ -18819,9 +18819,9 @@
             <a:r>
               <a:rPr lang="en-US" sz="875" b="1" dirty="0">
                 <a:solidFill>
-                  <a:srgbClr val="FFFFFF"/>
-                </a:solidFill>
-                <a:latin typeface="Bitter" pitchFamily="34" charset="0"/>
+                  <a:srgbClr val="2B2E3C"/>
+                </a:solidFill>
+                <a:latin typeface="Calibri" pitchFamily="34" charset="0"/>
                 <a:ea typeface="Bitter" pitchFamily="34" charset="-122"/>
                 <a:cs typeface="Bitter" pitchFamily="34" charset="-120"/>
               </a:rPr>
@@ -18858,9 +18858,9 @@
             <a:r>
               <a:rPr lang="en-US" sz="812" b="1" dirty="0">
                 <a:solidFill>
-                  <a:srgbClr val="FFFFFF"/>
-                </a:solidFill>
-                <a:latin typeface="Bitter" pitchFamily="34" charset="0"/>
+                  <a:srgbClr val="2B2E3C"/>
+                </a:solidFill>
+                <a:latin typeface="Calibri" pitchFamily="34" charset="0"/>
                 <a:ea typeface="Bitter" pitchFamily="34" charset="-122"/>
                 <a:cs typeface="Bitter" pitchFamily="34" charset="-120"/>
               </a:rPr>
@@ -18897,9 +18897,9 @@
             <a:r>
               <a:rPr lang="en-US" sz="656" dirty="0">
                 <a:solidFill>
-                  <a:srgbClr val="AABCB6"/>
-                </a:solidFill>
-                <a:latin typeface="Roboto" pitchFamily="34" charset="0"/>
+                  <a:srgbClr val="2B2E3C"/>
+                </a:solidFill>
+                <a:latin typeface="Calibri" pitchFamily="34" charset="0"/>
                 <a:ea typeface="Roboto" pitchFamily="34" charset="-122"/>
                 <a:cs typeface="Roboto" pitchFamily="34" charset="-120"/>
               </a:rPr>
@@ -18924,7 +18924,7 @@
             <a:avLst/>
           </a:prstGeom>
           <a:solidFill>
-            <a:srgbClr val="182A2E"/>
+            <a:srgbClr val="FFF8F0"/>
           </a:solidFill>
           <a:ln w="12700">
             <a:solidFill>
@@ -18994,9 +18994,9 @@
             <a:r>
               <a:rPr lang="en-US" sz="687" b="1" spc="300" kern="0" dirty="0">
                 <a:solidFill>
-                  <a:srgbClr val="E2C8B5"/>
-                </a:solidFill>
-                <a:latin typeface="Open Sans" pitchFamily="34" charset="0"/>
+                  <a:srgbClr val="AF2C20"/>
+                </a:solidFill>
+                <a:latin typeface="Calibri" pitchFamily="34" charset="0"/>
                 <a:ea typeface="Open Sans" pitchFamily="34" charset="-122"/>
                 <a:cs typeface="Open Sans" pitchFamily="34" charset="-120"/>
               </a:rPr>
@@ -19033,9 +19033,9 @@
             <a:r>
               <a:rPr lang="en-US" sz="593" dirty="0">
                 <a:solidFill>
-                  <a:srgbClr val="AABCB6"/>
-                </a:solidFill>
-                <a:latin typeface="Roboto" pitchFamily="34" charset="0"/>
+                  <a:srgbClr val="2B2E3C"/>
+                </a:solidFill>
+                <a:latin typeface="Calibri" pitchFamily="34" charset="0"/>
                 <a:ea typeface="Roboto" pitchFamily="34" charset="-122"/>
                 <a:cs typeface="Roboto" pitchFamily="34" charset="-120"/>
               </a:rPr>
@@ -19072,9 +19072,9 @@
             <a:r>
               <a:rPr lang="en-US" sz="593" dirty="0">
                 <a:solidFill>
-                  <a:srgbClr val="AABCB6"/>
-                </a:solidFill>
-                <a:latin typeface="Roboto" pitchFamily="34" charset="0"/>
+                  <a:srgbClr val="2B2E3C"/>
+                </a:solidFill>
+                <a:latin typeface="Calibri" pitchFamily="34" charset="0"/>
                 <a:ea typeface="Roboto" pitchFamily="34" charset="-122"/>
                 <a:cs typeface="Roboto" pitchFamily="34" charset="-120"/>
               </a:rPr>
@@ -19111,9 +19111,9 @@
             <a:r>
               <a:rPr lang="en-US" sz="593" dirty="0">
                 <a:solidFill>
-                  <a:srgbClr val="AABCB6"/>
-                </a:solidFill>
-                <a:latin typeface="Roboto" pitchFamily="34" charset="0"/>
+                  <a:srgbClr val="2B2E3C"/>
+                </a:solidFill>
+                <a:latin typeface="Calibri" pitchFamily="34" charset="0"/>
                 <a:ea typeface="Roboto" pitchFamily="34" charset="-122"/>
                 <a:cs typeface="Roboto" pitchFamily="34" charset="-120"/>
               </a:rPr>
@@ -19150,9 +19150,9 @@
             <a:r>
               <a:rPr lang="en-US" sz="593" dirty="0">
                 <a:solidFill>
-                  <a:srgbClr val="AABCB6"/>
-                </a:solidFill>
-                <a:latin typeface="Roboto" pitchFamily="34" charset="0"/>
+                  <a:srgbClr val="2B2E3C"/>
+                </a:solidFill>
+                <a:latin typeface="Calibri" pitchFamily="34" charset="0"/>
                 <a:ea typeface="Roboto" pitchFamily="34" charset="-122"/>
                 <a:cs typeface="Roboto" pitchFamily="34" charset="-120"/>
               </a:rPr>
@@ -19189,9 +19189,9 @@
             <a:r>
               <a:rPr lang="en-US" sz="593" dirty="0">
                 <a:solidFill>
-                  <a:srgbClr val="AABCB6"/>
-                </a:solidFill>
-                <a:latin typeface="Roboto" pitchFamily="34" charset="0"/>
+                  <a:srgbClr val="2B2E3C"/>
+                </a:solidFill>
+                <a:latin typeface="Calibri" pitchFamily="34" charset="0"/>
                 <a:ea typeface="Roboto" pitchFamily="34" charset="-122"/>
                 <a:cs typeface="Roboto" pitchFamily="34" charset="-120"/>
               </a:rPr>
@@ -19228,9 +19228,9 @@
             <a:r>
               <a:rPr lang="en-US" sz="593" dirty="0">
                 <a:solidFill>
-                  <a:srgbClr val="AABCB6"/>
-                </a:solidFill>
-                <a:latin typeface="Roboto" pitchFamily="34" charset="0"/>
+                  <a:srgbClr val="2B2E3C"/>
+                </a:solidFill>
+                <a:latin typeface="Calibri" pitchFamily="34" charset="0"/>
                 <a:ea typeface="Roboto" pitchFamily="34" charset="-122"/>
                 <a:cs typeface="Roboto" pitchFamily="34" charset="-120"/>
               </a:rPr>
@@ -19267,9 +19267,9 @@
             <a:r>
               <a:rPr lang="en-US" sz="593" dirty="0">
                 <a:solidFill>
-                  <a:srgbClr val="AABCB6"/>
-                </a:solidFill>
-                <a:latin typeface="Roboto" pitchFamily="34" charset="0"/>
+                  <a:srgbClr val="2B2E3C"/>
+                </a:solidFill>
+                <a:latin typeface="Calibri" pitchFamily="34" charset="0"/>
                 <a:ea typeface="Roboto" pitchFamily="34" charset="-122"/>
                 <a:cs typeface="Roboto" pitchFamily="34" charset="-120"/>
               </a:rPr>
@@ -19306,9 +19306,9 @@
             <a:r>
               <a:rPr lang="en-US" sz="593" dirty="0">
                 <a:solidFill>
-                  <a:srgbClr val="AABCB6"/>
-                </a:solidFill>
-                <a:latin typeface="Roboto" pitchFamily="34" charset="0"/>
+                  <a:srgbClr val="2B2E3C"/>
+                </a:solidFill>
+                <a:latin typeface="Calibri" pitchFamily="34" charset="0"/>
                 <a:ea typeface="Roboto" pitchFamily="34" charset="-122"/>
                 <a:cs typeface="Roboto" pitchFamily="34" charset="-120"/>
               </a:rPr>
@@ -19374,9 +19374,9 @@
             <a:r>
               <a:rPr lang="en-US" sz="625" dirty="0">
                 <a:solidFill>
-                  <a:srgbClr val="FFFFFF"/>
-                </a:solidFill>
-                <a:latin typeface="Open Sans" pitchFamily="34" charset="0"/>
+                  <a:srgbClr val="2B2E3C"/>
+                </a:solidFill>
+                <a:latin typeface="Calibri" pitchFamily="34" charset="0"/>
                 <a:ea typeface="Open Sans" pitchFamily="34" charset="-122"/>
                 <a:cs typeface="Open Sans" pitchFamily="34" charset="-120"/>
               </a:rPr>

</xml_diff>